<commit_message>
Fixes + added a new one (lab 2)
</commit_message>
<xml_diff>
--- a/slides/K8s.pptx
+++ b/slides/K8s.pptx
@@ -19,18 +19,20 @@
     <p:sldId id="264" r:id="rId13"/>
     <p:sldId id="260" r:id="rId14"/>
     <p:sldId id="267" r:id="rId15"/>
-    <p:sldId id="274" r:id="rId16"/>
-    <p:sldId id="268" r:id="rId17"/>
-    <p:sldId id="269" r:id="rId18"/>
-    <p:sldId id="273" r:id="rId19"/>
-    <p:sldId id="270" r:id="rId20"/>
-    <p:sldId id="271" r:id="rId21"/>
-    <p:sldId id="272" r:id="rId22"/>
-    <p:sldId id="275" r:id="rId23"/>
-    <p:sldId id="277" r:id="rId24"/>
-    <p:sldId id="280" r:id="rId25"/>
-    <p:sldId id="281" r:id="rId26"/>
-    <p:sldId id="276" r:id="rId27"/>
+    <p:sldId id="283" r:id="rId16"/>
+    <p:sldId id="282" r:id="rId17"/>
+    <p:sldId id="274" r:id="rId18"/>
+    <p:sldId id="268" r:id="rId19"/>
+    <p:sldId id="269" r:id="rId20"/>
+    <p:sldId id="273" r:id="rId21"/>
+    <p:sldId id="270" r:id="rId22"/>
+    <p:sldId id="271" r:id="rId23"/>
+    <p:sldId id="272" r:id="rId24"/>
+    <p:sldId id="275" r:id="rId25"/>
+    <p:sldId id="277" r:id="rId26"/>
+    <p:sldId id="280" r:id="rId27"/>
+    <p:sldId id="281" r:id="rId28"/>
+    <p:sldId id="276" r:id="rId29"/>
   </p:sldIdLst>
   <p:sldSz cx="12192000" cy="6858000"/>
   <p:notesSz cx="6858000" cy="9144000"/>
@@ -284,7 +286,7 @@
           <a:p>
             <a:fld id="{519BAEA6-88FC-4542-B3BF-F11A57CC5938}" type="datetimeFigureOut">
               <a:rPr lang="ru-RU" smtClean="0"/>
-              <a:t>15.07.2026</a:t>
+              <a:t>16.07.2026</a:t>
             </a:fld>
             <a:endParaRPr lang="ru-RU"/>
           </a:p>
@@ -482,7 +484,7 @@
           <a:p>
             <a:fld id="{519BAEA6-88FC-4542-B3BF-F11A57CC5938}" type="datetimeFigureOut">
               <a:rPr lang="ru-RU" smtClean="0"/>
-              <a:t>15.07.2026</a:t>
+              <a:t>16.07.2026</a:t>
             </a:fld>
             <a:endParaRPr lang="ru-RU"/>
           </a:p>
@@ -690,7 +692,7 @@
           <a:p>
             <a:fld id="{519BAEA6-88FC-4542-B3BF-F11A57CC5938}" type="datetimeFigureOut">
               <a:rPr lang="ru-RU" smtClean="0"/>
-              <a:t>15.07.2026</a:t>
+              <a:t>16.07.2026</a:t>
             </a:fld>
             <a:endParaRPr lang="ru-RU"/>
           </a:p>
@@ -888,7 +890,7 @@
           <a:p>
             <a:fld id="{519BAEA6-88FC-4542-B3BF-F11A57CC5938}" type="datetimeFigureOut">
               <a:rPr lang="ru-RU" smtClean="0"/>
-              <a:t>15.07.2026</a:t>
+              <a:t>16.07.2026</a:t>
             </a:fld>
             <a:endParaRPr lang="ru-RU"/>
           </a:p>
@@ -1163,7 +1165,7 @@
           <a:p>
             <a:fld id="{519BAEA6-88FC-4542-B3BF-F11A57CC5938}" type="datetimeFigureOut">
               <a:rPr lang="ru-RU" smtClean="0"/>
-              <a:t>15.07.2026</a:t>
+              <a:t>16.07.2026</a:t>
             </a:fld>
             <a:endParaRPr lang="ru-RU"/>
           </a:p>
@@ -1428,7 +1430,7 @@
           <a:p>
             <a:fld id="{519BAEA6-88FC-4542-B3BF-F11A57CC5938}" type="datetimeFigureOut">
               <a:rPr lang="ru-RU" smtClean="0"/>
-              <a:t>15.07.2026</a:t>
+              <a:t>16.07.2026</a:t>
             </a:fld>
             <a:endParaRPr lang="ru-RU"/>
           </a:p>
@@ -1840,7 +1842,7 @@
           <a:p>
             <a:fld id="{519BAEA6-88FC-4542-B3BF-F11A57CC5938}" type="datetimeFigureOut">
               <a:rPr lang="ru-RU" smtClean="0"/>
-              <a:t>15.07.2026</a:t>
+              <a:t>16.07.2026</a:t>
             </a:fld>
             <a:endParaRPr lang="ru-RU"/>
           </a:p>
@@ -1981,7 +1983,7 @@
           <a:p>
             <a:fld id="{519BAEA6-88FC-4542-B3BF-F11A57CC5938}" type="datetimeFigureOut">
               <a:rPr lang="ru-RU" smtClean="0"/>
-              <a:t>15.07.2026</a:t>
+              <a:t>16.07.2026</a:t>
             </a:fld>
             <a:endParaRPr lang="ru-RU"/>
           </a:p>
@@ -2094,7 +2096,7 @@
           <a:p>
             <a:fld id="{519BAEA6-88FC-4542-B3BF-F11A57CC5938}" type="datetimeFigureOut">
               <a:rPr lang="ru-RU" smtClean="0"/>
-              <a:t>15.07.2026</a:t>
+              <a:t>16.07.2026</a:t>
             </a:fld>
             <a:endParaRPr lang="ru-RU"/>
           </a:p>
@@ -2405,7 +2407,7 @@
           <a:p>
             <a:fld id="{519BAEA6-88FC-4542-B3BF-F11A57CC5938}" type="datetimeFigureOut">
               <a:rPr lang="ru-RU" smtClean="0"/>
-              <a:t>15.07.2026</a:t>
+              <a:t>16.07.2026</a:t>
             </a:fld>
             <a:endParaRPr lang="ru-RU"/>
           </a:p>
@@ -2693,7 +2695,7 @@
           <a:p>
             <a:fld id="{519BAEA6-88FC-4542-B3BF-F11A57CC5938}" type="datetimeFigureOut">
               <a:rPr lang="ru-RU" smtClean="0"/>
-              <a:t>15.07.2026</a:t>
+              <a:t>16.07.2026</a:t>
             </a:fld>
             <a:endParaRPr lang="ru-RU"/>
           </a:p>
@@ -2943,7 +2945,7 @@
           <a:p>
             <a:fld id="{519BAEA6-88FC-4542-B3BF-F11A57CC5938}" type="datetimeFigureOut">
               <a:rPr lang="ru-RU" smtClean="0"/>
-              <a:t>15.07.2026</a:t>
+              <a:t>16.07.2026</a:t>
             </a:fld>
             <a:endParaRPr lang="ru-RU"/>
           </a:p>
@@ -4524,8 +4526,25 @@
                   </a:schemeClr>
                 </a:solidFill>
               </a:rPr>
-              <a:t>Общие концепции. Kubernetes Service</a:t>
-            </a:r>
+              <a:t>Общие концепции. </a:t>
+            </a:r>
+            <a:r>
+              <a:rPr lang="ru-RU" b="1" dirty="0" err="1">
+                <a:solidFill>
+                  <a:schemeClr val="accent1">
+                    <a:lumMod val="75000"/>
+                  </a:schemeClr>
+                </a:solidFill>
+              </a:rPr>
+              <a:t>Helm</a:t>
+            </a:r>
+            <a:endParaRPr lang="ru-RU" b="1" dirty="0">
+              <a:solidFill>
+                <a:schemeClr val="accent1">
+                  <a:lumMod val="75000"/>
+                </a:schemeClr>
+              </a:solidFill>
+            </a:endParaRPr>
           </a:p>
         </p:txBody>
       </p:sp>
@@ -4545,10 +4564,15 @@
             <p:ph idx="1"/>
           </p:nvPr>
         </p:nvSpPr>
-        <p:spPr/>
+        <p:spPr>
+          <a:xfrm>
+            <a:off x="838200" y="1825624"/>
+            <a:ext cx="10701528" cy="4758056"/>
+          </a:xfrm>
+        </p:spPr>
         <p:txBody>
           <a:bodyPr>
-            <a:normAutofit fontScale="70000" lnSpcReduction="20000"/>
+            <a:normAutofit fontScale="77500" lnSpcReduction="20000"/>
           </a:bodyPr>
           <a:lstStyle/>
           <a:p>
@@ -4556,12 +4580,216 @@
               <a:buNone/>
             </a:pPr>
             <a:r>
+              <a:rPr lang="ru-RU" b="1" dirty="0" err="1"/>
+              <a:t>Helm</a:t>
+            </a:r>
+            <a:r>
+              <a:rPr lang="ru-RU" dirty="0"/>
+              <a:t> – пакетный менеджер для </a:t>
+            </a:r>
+            <a:r>
               <a:rPr lang="ru-RU" dirty="0" err="1"/>
-              <a:t>Pods</a:t>
-            </a:r>
-            <a:r>
-              <a:rPr lang="ru-RU" dirty="0"/>
-              <a:t> – это «расходный материал». Они могут завершаться, пересоздаваться или масштабироваться, поэтому при каждом создании получают новый IP-адрес. Из-за этого обращаться к </a:t>
+              <a:t>Kubernetes</a:t>
+            </a:r>
+            <a:r>
+              <a:rPr lang="ru-RU" dirty="0"/>
+              <a:t>, который позволяет устанавливать, обновлять и откатывать приложения как единое целое. </a:t>
+            </a:r>
+          </a:p>
+          <a:p>
+            <a:pPr marL="0" indent="0">
+              <a:buNone/>
+            </a:pPr>
+            <a:r>
+              <a:rPr lang="ru-RU" b="1" dirty="0" err="1"/>
+              <a:t>Chart</a:t>
+            </a:r>
+            <a:r>
+              <a:rPr lang="ru-RU" b="1" dirty="0"/>
+              <a:t> </a:t>
+            </a:r>
+            <a:r>
+              <a:rPr lang="ru-RU" dirty="0"/>
+              <a:t>– шаблон (пакет), содержащий описание ресурсов </a:t>
+            </a:r>
+            <a:r>
+              <a:rPr lang="en-US" dirty="0"/>
+              <a:t>Kubernetes (Deployment, Service, </a:t>
+            </a:r>
+            <a:r>
+              <a:rPr lang="en-US" dirty="0" err="1"/>
+              <a:t>ConfigMap</a:t>
+            </a:r>
+            <a:r>
+              <a:rPr lang="en-US" dirty="0"/>
+              <a:t>, Secret, Ingress </a:t>
+            </a:r>
+            <a:r>
+              <a:rPr lang="ru-RU" dirty="0"/>
+              <a:t>и др.) и параметры их настройки.</a:t>
+            </a:r>
+          </a:p>
+          <a:p>
+            <a:pPr marL="0" indent="0">
+              <a:buNone/>
+            </a:pPr>
+            <a:r>
+              <a:rPr lang="ru-RU" b="1" dirty="0" err="1"/>
+              <a:t>Release</a:t>
+            </a:r>
+            <a:r>
+              <a:rPr lang="ru-RU" b="1" dirty="0"/>
+              <a:t> </a:t>
+            </a:r>
+            <a:r>
+              <a:rPr lang="ru-RU" dirty="0"/>
+              <a:t>– это установленный экземпляр </a:t>
+            </a:r>
+            <a:r>
+              <a:rPr lang="ru-RU" dirty="0" err="1"/>
+              <a:t>Chart</a:t>
+            </a:r>
+            <a:r>
+              <a:rPr lang="ru-RU" dirty="0"/>
+              <a:t> в </a:t>
+            </a:r>
+            <a:r>
+              <a:rPr lang="ru-RU" dirty="0" err="1"/>
+              <a:t>Kubernetes</a:t>
+            </a:r>
+            <a:r>
+              <a:rPr lang="ru-RU" dirty="0"/>
+              <a:t>. Один и тот же </a:t>
+            </a:r>
+            <a:r>
+              <a:rPr lang="ru-RU" dirty="0" err="1"/>
+              <a:t>Chart</a:t>
+            </a:r>
+            <a:r>
+              <a:rPr lang="ru-RU" dirty="0"/>
+              <a:t> можно развернуть несколько раз с разными параметрами — получится несколько независимых </a:t>
+            </a:r>
+            <a:r>
+              <a:rPr lang="ru-RU" dirty="0" err="1"/>
+              <a:t>Release</a:t>
+            </a:r>
+            <a:r>
+              <a:rPr lang="ru-RU" dirty="0"/>
+              <a:t>.</a:t>
+            </a:r>
+          </a:p>
+          <a:p>
+            <a:pPr marL="0" indent="0">
+              <a:buNone/>
+            </a:pPr>
+            <a:r>
+              <a:rPr lang="ru-RU" b="1" dirty="0"/>
+              <a:t>Что полезно знать QA:</a:t>
+            </a:r>
+          </a:p>
+          <a:p>
+            <a:pPr>
+              <a:spcBef>
+                <a:spcPts val="600"/>
+              </a:spcBef>
+            </a:pPr>
+            <a:r>
+              <a:rPr lang="ru-RU" dirty="0"/>
+              <a:t>большинство приложений в </a:t>
+            </a:r>
+            <a:r>
+              <a:rPr lang="ru-RU" dirty="0" err="1"/>
+              <a:t>Kubernetes</a:t>
+            </a:r>
+            <a:r>
+              <a:rPr lang="ru-RU" dirty="0"/>
+              <a:t> разворачиваются через </a:t>
+            </a:r>
+            <a:r>
+              <a:rPr lang="ru-RU" dirty="0" err="1"/>
+              <a:t>Helm</a:t>
+            </a:r>
+            <a:r>
+              <a:rPr lang="ru-RU" dirty="0"/>
+              <a:t>; </a:t>
+            </a:r>
+          </a:p>
+          <a:p>
+            <a:pPr>
+              <a:spcBef>
+                <a:spcPts val="600"/>
+              </a:spcBef>
+            </a:pPr>
+            <a:r>
+              <a:rPr lang="ru-RU" dirty="0"/>
+              <a:t>история изменений </a:t>
+            </a:r>
+            <a:r>
+              <a:rPr lang="ru-RU" dirty="0" err="1"/>
+              <a:t>Release</a:t>
+            </a:r>
+            <a:r>
+              <a:rPr lang="ru-RU" dirty="0"/>
+              <a:t> хранится в кластере и может быть просмотрена командой </a:t>
+            </a:r>
+            <a:r>
+              <a:rPr lang="ru-RU" dirty="0" err="1"/>
+              <a:t>helm</a:t>
+            </a:r>
+            <a:r>
+              <a:rPr lang="ru-RU" dirty="0"/>
+              <a:t> </a:t>
+            </a:r>
+            <a:r>
+              <a:rPr lang="ru-RU" dirty="0" err="1"/>
+              <a:t>history</a:t>
+            </a:r>
+            <a:r>
+              <a:rPr lang="ru-RU" dirty="0"/>
+              <a:t>; </a:t>
+            </a:r>
+          </a:p>
+          <a:p>
+            <a:pPr>
+              <a:spcBef>
+                <a:spcPts val="600"/>
+              </a:spcBef>
+            </a:pPr>
+            <a:r>
+              <a:rPr lang="ru-RU" dirty="0"/>
+              <a:t>все ресурсы одного </a:t>
+            </a:r>
+            <a:r>
+              <a:rPr lang="ru-RU" dirty="0" err="1"/>
+              <a:t>Release</a:t>
+            </a:r>
+            <a:r>
+              <a:rPr lang="ru-RU" dirty="0"/>
+              <a:t> имеют общую метку app.kubernetes.io/</a:t>
+            </a:r>
+            <a:r>
+              <a:rPr lang="ru-RU" dirty="0" err="1"/>
+              <a:t>instance</a:t>
+            </a:r>
+            <a:r>
+              <a:rPr lang="ru-RU" dirty="0"/>
+              <a:t>=&lt;</a:t>
+            </a:r>
+            <a:r>
+              <a:rPr lang="ru-RU" dirty="0" err="1"/>
+              <a:t>release-name</a:t>
+            </a:r>
+            <a:r>
+              <a:rPr lang="ru-RU" dirty="0"/>
+              <a:t>&gt;, что упрощает поиск связанных </a:t>
+            </a:r>
+            <a:r>
+              <a:rPr lang="ru-RU" dirty="0" err="1"/>
+              <a:t>Deployment</a:t>
+            </a:r>
+            <a:r>
+              <a:rPr lang="ru-RU" dirty="0"/>
+              <a:t>, </a:t>
             </a:r>
             <a:r>
               <a:rPr lang="ru-RU" dirty="0" err="1"/>
@@ -4569,259 +4797,44 @@
             </a:r>
             <a:r>
               <a:rPr lang="ru-RU" dirty="0"/>
-              <a:t> напрямую нельзя.</a:t>
-            </a:r>
-          </a:p>
-          <a:p>
-            <a:pPr marL="0" indent="0">
-              <a:buNone/>
+              <a:t>, Service, </a:t>
+            </a:r>
+            <a:r>
+              <a:rPr lang="ru-RU" dirty="0" err="1"/>
+              <a:t>ConfigMap</a:t>
+            </a:r>
+            <a:r>
+              <a:rPr lang="ru-RU" dirty="0"/>
+              <a:t> и других объектов; </a:t>
+            </a:r>
+          </a:p>
+          <a:p>
+            <a:pPr>
+              <a:spcBef>
+                <a:spcPts val="600"/>
+              </a:spcBef>
             </a:pPr>
             <a:r>
               <a:rPr lang="ru-RU" dirty="0"/>
-              <a:t>Для решения этой проблемы используется </a:t>
-            </a:r>
-            <a:r>
-              <a:rPr lang="ru-RU" b="1" dirty="0"/>
-              <a:t>Service</a:t>
+              <a:t>при неудачном обновлении приложение можно вернуть к предыдущей версии командой </a:t>
+            </a:r>
+            <a:r>
+              <a:rPr lang="ru-RU" dirty="0" err="1"/>
+              <a:t>helm</a:t>
+            </a:r>
+            <a:r>
+              <a:rPr lang="ru-RU" dirty="0"/>
+              <a:t> </a:t>
+            </a:r>
+            <a:r>
+              <a:rPr lang="ru-RU" dirty="0" err="1"/>
+              <a:t>rollback</a:t>
             </a:r>
             <a:r>
               <a:rPr lang="ru-RU" dirty="0"/>
               <a:t>.</a:t>
             </a:r>
-          </a:p>
-          <a:p>
-            <a:pPr marL="0" indent="0">
-              <a:buNone/>
-            </a:pPr>
-            <a:r>
-              <a:rPr lang="ru-RU" b="1" dirty="0"/>
-              <a:t>Service</a:t>
-            </a:r>
-            <a:r>
-              <a:rPr lang="ru-RU" dirty="0"/>
-              <a:t> – это объект </a:t>
-            </a:r>
-            <a:r>
-              <a:rPr lang="ru-RU" dirty="0" err="1"/>
-              <a:t>Kubernetes</a:t>
-            </a:r>
-            <a:r>
-              <a:rPr lang="ru-RU" dirty="0"/>
-              <a:t>, который предоставляет группе </a:t>
-            </a:r>
-            <a:r>
-              <a:rPr lang="ru-RU" dirty="0" err="1"/>
-              <a:t>Pod'ов</a:t>
-            </a:r>
-            <a:r>
-              <a:rPr lang="ru-RU" dirty="0"/>
-              <a:t> один постоянный внутренний IP-адрес и DNS-имя. Клиенты обращаются к Service, а </a:t>
-            </a:r>
-            <a:r>
-              <a:rPr lang="ru-RU" dirty="0" err="1"/>
-              <a:t>Kubernetes</a:t>
-            </a:r>
-            <a:r>
-              <a:rPr lang="ru-RU" dirty="0"/>
-              <a:t> автоматически перенаправляет запрос на один из подходящих </a:t>
-            </a:r>
-            <a:r>
-              <a:rPr lang="ru-RU" dirty="0" err="1"/>
-              <a:t>Pod'ов</a:t>
-            </a:r>
-            <a:r>
-              <a:rPr lang="ru-RU" dirty="0"/>
-              <a:t>.</a:t>
-            </a:r>
-          </a:p>
-          <a:p>
-            <a:pPr marL="0" indent="0">
-              <a:buNone/>
-            </a:pPr>
-            <a:r>
-              <a:rPr lang="ru-RU" b="1" dirty="0"/>
-              <a:t>Как Service находит нужные </a:t>
-            </a:r>
-            <a:r>
-              <a:rPr lang="ru-RU" b="1" dirty="0" err="1"/>
-              <a:t>Pod'ы</a:t>
-            </a:r>
-            <a:r>
-              <a:rPr lang="ru-RU" b="1" dirty="0"/>
-              <a:t>?</a:t>
-            </a:r>
-            <a:endParaRPr lang="ru-RU" dirty="0"/>
-          </a:p>
-          <a:p>
-            <a:r>
-              <a:rPr lang="ru-RU" b="1" dirty="0" err="1"/>
-              <a:t>Labels</a:t>
-            </a:r>
-            <a:r>
-              <a:rPr lang="ru-RU" b="1" dirty="0"/>
-              <a:t> (метки)</a:t>
-            </a:r>
-            <a:r>
-              <a:rPr lang="ru-RU" dirty="0"/>
-              <a:t> – назначаются </a:t>
-            </a:r>
-            <a:r>
-              <a:rPr lang="ru-RU" dirty="0" err="1"/>
-              <a:t>Pod'ам</a:t>
-            </a:r>
-            <a:r>
-              <a:rPr lang="ru-RU" dirty="0"/>
-              <a:t> (например, </a:t>
-            </a:r>
-            <a:r>
-              <a:rPr lang="ru-RU" dirty="0" err="1"/>
-              <a:t>app</a:t>
-            </a:r>
-            <a:r>
-              <a:rPr lang="ru-RU" dirty="0"/>
-              <a:t>: </a:t>
-            </a:r>
-            <a:r>
-              <a:rPr lang="ru-RU" dirty="0" err="1"/>
-              <a:t>payment-gateway</a:t>
-            </a:r>
-            <a:r>
-              <a:rPr lang="ru-RU" dirty="0"/>
-              <a:t>).</a:t>
-            </a:r>
-          </a:p>
-          <a:p>
-            <a:r>
-              <a:rPr lang="ru-RU" b="1" dirty="0" err="1"/>
-              <a:t>Selector</a:t>
-            </a:r>
-            <a:r>
-              <a:rPr lang="ru-RU" b="1" dirty="0"/>
-              <a:t> (селектор)</a:t>
-            </a:r>
-            <a:r>
-              <a:rPr lang="ru-RU" dirty="0"/>
-              <a:t> – указывается в Service и определяет, какие </a:t>
-            </a:r>
-            <a:r>
-              <a:rPr lang="ru-RU" dirty="0" err="1"/>
-              <a:t>Pod'ы</a:t>
-            </a:r>
-            <a:r>
-              <a:rPr lang="ru-RU" dirty="0"/>
-              <a:t> должны обслуживать запросы.</a:t>
-            </a:r>
-          </a:p>
-          <a:p>
-            <a:r>
-              <a:rPr lang="ru-RU" b="1" dirty="0" err="1"/>
-              <a:t>Endpoints</a:t>
-            </a:r>
-            <a:r>
-              <a:rPr lang="ru-RU" b="1" dirty="0"/>
-              <a:t> (конечные точки)</a:t>
-            </a:r>
-            <a:r>
-              <a:rPr lang="ru-RU" dirty="0"/>
-              <a:t> – </a:t>
-            </a:r>
-            <a:r>
-              <a:rPr lang="ru-RU" dirty="0" err="1"/>
-              <a:t>Kubernetes</a:t>
-            </a:r>
-            <a:r>
-              <a:rPr lang="ru-RU" dirty="0"/>
-              <a:t> автоматически формирует список IP-адресов всех </a:t>
-            </a:r>
-            <a:r>
-              <a:rPr lang="ru-RU" b="1" dirty="0"/>
-              <a:t>готовых</a:t>
-            </a:r>
-            <a:r>
-              <a:rPr lang="ru-RU" dirty="0"/>
-              <a:t> </a:t>
-            </a:r>
-            <a:r>
-              <a:rPr lang="ru-RU" dirty="0" err="1"/>
-              <a:t>Pod'ов</a:t>
-            </a:r>
-            <a:r>
-              <a:rPr lang="ru-RU" dirty="0"/>
-              <a:t>, подходящих под селектор. Именно на них Service распределяет входящий трафик.</a:t>
-            </a:r>
-            <a:br>
-              <a:rPr lang="ru-RU" dirty="0"/>
-            </a:br>
-            <a:r>
-              <a:rPr lang="ru-RU" i="1" dirty="0">
-                <a:solidFill>
-                  <a:schemeClr val="accent1">
-                    <a:lumMod val="75000"/>
-                  </a:schemeClr>
-                </a:solidFill>
-              </a:rPr>
-              <a:t>Если подходящих </a:t>
-            </a:r>
-            <a:r>
-              <a:rPr lang="ru-RU" i="1" dirty="0" err="1">
-                <a:solidFill>
-                  <a:schemeClr val="accent1">
-                    <a:lumMod val="75000"/>
-                  </a:schemeClr>
-                </a:solidFill>
-              </a:rPr>
-              <a:t>Pod'ов</a:t>
-            </a:r>
-            <a:r>
-              <a:rPr lang="ru-RU" i="1" dirty="0">
-                <a:solidFill>
-                  <a:schemeClr val="accent1">
-                    <a:lumMod val="75000"/>
-                  </a:schemeClr>
-                </a:solidFill>
-              </a:rPr>
-              <a:t> нет или они не готовы (</a:t>
-            </a:r>
-            <a:r>
-              <a:rPr lang="ru-RU" b="1" i="1" dirty="0">
-                <a:solidFill>
-                  <a:schemeClr val="accent1">
-                    <a:lumMod val="75000"/>
-                  </a:schemeClr>
-                </a:solidFill>
-              </a:rPr>
-              <a:t>Ready</a:t>
-            </a:r>
-            <a:r>
-              <a:rPr lang="ru-RU" i="1" dirty="0">
-                <a:solidFill>
-                  <a:schemeClr val="accent1">
-                    <a:lumMod val="75000"/>
-                  </a:schemeClr>
-                </a:solidFill>
-              </a:rPr>
-              <a:t>), список </a:t>
-            </a:r>
-            <a:r>
-              <a:rPr lang="ru-RU" i="1" dirty="0" err="1">
-                <a:solidFill>
-                  <a:schemeClr val="accent1">
-                    <a:lumMod val="75000"/>
-                  </a:schemeClr>
-                </a:solidFill>
-              </a:rPr>
-              <a:t>Endpoints</a:t>
-            </a:r>
-            <a:r>
-              <a:rPr lang="ru-RU" i="1" dirty="0">
-                <a:solidFill>
-                  <a:schemeClr val="accent1">
-                    <a:lumMod val="75000"/>
-                  </a:schemeClr>
-                </a:solidFill>
-              </a:rPr>
-              <a:t> будет пустым, и Service не сможет направить трафик.</a:t>
-            </a:r>
+            <a:endParaRPr lang="ru-RU" b="1" dirty="0"/>
           </a:p>
         </p:txBody>
       </p:sp>
@@ -4839,6 +4852,776 @@
 </file>
 
 <file path=ppt/slides/slide15.xml><?xml version="1.0" encoding="utf-8"?>
+<p:sld xmlns:a="http://schemas.openxmlformats.org/drawingml/2006/main" xmlns:r="http://schemas.openxmlformats.org/officeDocument/2006/relationships" xmlns:p="http://schemas.openxmlformats.org/presentationml/2006/main">
+  <p:cSld>
+    <p:spTree>
+      <p:nvGrpSpPr>
+        <p:cNvPr id="1" name="">
+          <a:extLst>
+            <a:ext uri="{FF2B5EF4-FFF2-40B4-BE49-F238E27FC236}">
+              <a16:creationId xmlns:a16="http://schemas.microsoft.com/office/drawing/2014/main" id="{836D7457-618C-930C-504B-56F329E6AC42}"/>
+            </a:ext>
+          </a:extLst>
+        </p:cNvPr>
+        <p:cNvGrpSpPr/>
+        <p:nvPr/>
+      </p:nvGrpSpPr>
+      <p:grpSpPr>
+        <a:xfrm>
+          <a:off x="0" y="0"/>
+          <a:ext cx="0" cy="0"/>
+          <a:chOff x="0" y="0"/>
+          <a:chExt cx="0" cy="0"/>
+        </a:xfrm>
+      </p:grpSpPr>
+      <p:sp>
+        <p:nvSpPr>
+          <p:cNvPr id="2" name="Заголовок 1">
+            <a:extLst>
+              <a:ext uri="{FF2B5EF4-FFF2-40B4-BE49-F238E27FC236}">
+                <a16:creationId xmlns:a16="http://schemas.microsoft.com/office/drawing/2014/main" id="{09261943-1259-3DC2-244A-6F7C5814808F}"/>
+              </a:ext>
+            </a:extLst>
+          </p:cNvPr>
+          <p:cNvSpPr>
+            <a:spLocks noGrp="1"/>
+          </p:cNvSpPr>
+          <p:nvPr>
+            <p:ph type="title"/>
+          </p:nvPr>
+        </p:nvSpPr>
+        <p:spPr/>
+        <p:txBody>
+          <a:bodyPr/>
+          <a:lstStyle/>
+          <a:p>
+            <a:r>
+              <a:rPr lang="ru-RU" b="1" dirty="0">
+                <a:solidFill>
+                  <a:schemeClr val="accent1">
+                    <a:lumMod val="75000"/>
+                  </a:schemeClr>
+                </a:solidFill>
+              </a:rPr>
+              <a:t>Общие концепции. </a:t>
+            </a:r>
+            <a:r>
+              <a:rPr lang="ru-RU" b="1" dirty="0" err="1">
+                <a:solidFill>
+                  <a:schemeClr val="accent1">
+                    <a:lumMod val="75000"/>
+                  </a:schemeClr>
+                </a:solidFill>
+              </a:rPr>
+              <a:t>Helm</a:t>
+            </a:r>
+            <a:endParaRPr lang="ru-RU" b="1" dirty="0">
+              <a:solidFill>
+                <a:schemeClr val="accent1">
+                  <a:lumMod val="75000"/>
+                </a:schemeClr>
+              </a:solidFill>
+            </a:endParaRPr>
+          </a:p>
+        </p:txBody>
+      </p:sp>
+      <p:sp>
+        <p:nvSpPr>
+          <p:cNvPr id="9" name="Объект 8">
+            <a:extLst>
+              <a:ext uri="{FF2B5EF4-FFF2-40B4-BE49-F238E27FC236}">
+                <a16:creationId xmlns:a16="http://schemas.microsoft.com/office/drawing/2014/main" id="{CB8533EB-888E-E400-EF33-3625CB072E53}"/>
+              </a:ext>
+            </a:extLst>
+          </p:cNvPr>
+          <p:cNvSpPr>
+            <a:spLocks noGrp="1"/>
+          </p:cNvSpPr>
+          <p:nvPr>
+            <p:ph idx="1"/>
+          </p:nvPr>
+        </p:nvSpPr>
+        <p:spPr>
+          <a:xfrm>
+            <a:off x="838200" y="1515363"/>
+            <a:ext cx="10515600" cy="4758056"/>
+          </a:xfrm>
+        </p:spPr>
+        <p:txBody>
+          <a:bodyPr>
+            <a:noAutofit/>
+          </a:bodyPr>
+          <a:lstStyle/>
+          <a:p>
+            <a:pPr marL="0" indent="0" latinLnBrk="1">
+              <a:buNone/>
+            </a:pPr>
+            <a:r>
+              <a:rPr lang="ru-RU" sz="2000" b="1" dirty="0"/>
+              <a:t>Типичные сценарии: </a:t>
+            </a:r>
+          </a:p>
+          <a:p>
+            <a:pPr fontAlgn="ctr">
+              <a:spcBef>
+                <a:spcPts val="600"/>
+              </a:spcBef>
+            </a:pPr>
+            <a:r>
+              <a:rPr lang="ru-RU" sz="2000" dirty="0"/>
+              <a:t>После обновления приложения перестали проходить тесты → Посмотреть </a:t>
+            </a:r>
+            <a:r>
+              <a:rPr lang="ru-RU" sz="2000" dirty="0" err="1"/>
+              <a:t>helm</a:t>
+            </a:r>
+            <a:r>
+              <a:rPr lang="ru-RU" sz="2000" dirty="0"/>
+              <a:t> </a:t>
+            </a:r>
+            <a:r>
+              <a:rPr lang="ru-RU" sz="2000" dirty="0" err="1"/>
+              <a:t>history</a:t>
+            </a:r>
+            <a:r>
+              <a:rPr lang="ru-RU" sz="2000" dirty="0"/>
+              <a:t>, чтобы определить, какая версия была развернута и когда произошло обновление.</a:t>
+            </a:r>
+          </a:p>
+          <a:p>
+            <a:pPr fontAlgn="ctr">
+              <a:spcBef>
+                <a:spcPts val="600"/>
+              </a:spcBef>
+            </a:pPr>
+            <a:r>
+              <a:rPr lang="ru-RU" sz="2000" dirty="0"/>
+              <a:t>Нужно проверить конфигурацию тестового стенда → найти </a:t>
+            </a:r>
+            <a:r>
+              <a:rPr lang="ru-RU" sz="2000" dirty="0" err="1"/>
+              <a:t>ConfigMap</a:t>
+            </a:r>
+            <a:r>
+              <a:rPr lang="ru-RU" sz="2000" dirty="0"/>
+              <a:t> или Secret, относящиеся к нужному </a:t>
+            </a:r>
+            <a:r>
+              <a:rPr lang="ru-RU" sz="2000" dirty="0" err="1"/>
+              <a:t>Release</a:t>
+            </a:r>
+            <a:r>
+              <a:rPr lang="ru-RU" sz="2000" dirty="0"/>
+              <a:t>.</a:t>
+            </a:r>
+          </a:p>
+          <a:p>
+            <a:pPr fontAlgn="ctr">
+              <a:spcBef>
+                <a:spcPts val="600"/>
+              </a:spcBef>
+            </a:pPr>
+            <a:r>
+              <a:rPr lang="ru-RU" sz="2000" dirty="0"/>
+              <a:t>После релиза возникли критические ошибки → при наличии необходимых прав выполнить </a:t>
+            </a:r>
+            <a:r>
+              <a:rPr lang="ru-RU" sz="2000" dirty="0" err="1"/>
+              <a:t>helm</a:t>
+            </a:r>
+            <a:r>
+              <a:rPr lang="ru-RU" sz="2000" dirty="0"/>
+              <a:t> </a:t>
+            </a:r>
+            <a:r>
+              <a:rPr lang="ru-RU" sz="2000" dirty="0" err="1"/>
+              <a:t>rollback</a:t>
+            </a:r>
+            <a:endParaRPr lang="ru-RU" sz="2000" dirty="0"/>
+          </a:p>
+          <a:p>
+            <a:pPr fontAlgn="ctr">
+              <a:spcBef>
+                <a:spcPts val="600"/>
+              </a:spcBef>
+            </a:pPr>
+            <a:r>
+              <a:rPr lang="ru-RU" sz="2000" dirty="0"/>
+              <a:t>Нужно узнать, какая версия приложения развернута на стенде→ посмотреть параметры текущего </a:t>
+            </a:r>
+            <a:r>
+              <a:rPr lang="ru-RU" sz="2000" dirty="0" err="1"/>
+              <a:t>Release</a:t>
+            </a:r>
+            <a:r>
+              <a:rPr lang="ru-RU" sz="2000" dirty="0"/>
+              <a:t> (</a:t>
+            </a:r>
+            <a:r>
+              <a:rPr lang="ru-RU" sz="2000" dirty="0" err="1"/>
+              <a:t>helm</a:t>
+            </a:r>
+            <a:r>
+              <a:rPr lang="ru-RU" sz="2000" dirty="0"/>
+              <a:t> </a:t>
+            </a:r>
+            <a:r>
+              <a:rPr lang="ru-RU" sz="2000" dirty="0" err="1"/>
+              <a:t>status</a:t>
+            </a:r>
+            <a:r>
+              <a:rPr lang="ru-RU" sz="2000" dirty="0"/>
+              <a:t>) или историю (</a:t>
+            </a:r>
+            <a:r>
+              <a:rPr lang="ru-RU" sz="2000" dirty="0" err="1"/>
+              <a:t>helm</a:t>
+            </a:r>
+            <a:r>
+              <a:rPr lang="ru-RU" sz="2000" dirty="0"/>
+              <a:t> </a:t>
+            </a:r>
+            <a:r>
+              <a:rPr lang="ru-RU" sz="2000" dirty="0" err="1"/>
+              <a:t>history</a:t>
+            </a:r>
+            <a:r>
+              <a:rPr lang="ru-RU" sz="2000" dirty="0"/>
+              <a:t>).</a:t>
+            </a:r>
+          </a:p>
+          <a:p>
+            <a:pPr marL="0" indent="0" fontAlgn="ctr">
+              <a:spcBef>
+                <a:spcPts val="600"/>
+              </a:spcBef>
+              <a:buNone/>
+            </a:pPr>
+            <a:r>
+              <a:rPr lang="ru-RU" sz="2000" b="1" dirty="0"/>
+              <a:t>Основные команды:</a:t>
+            </a:r>
+            <a:endParaRPr lang="ru-RU" sz="2000" dirty="0"/>
+          </a:p>
+          <a:p>
+            <a:pPr latinLnBrk="1"/>
+            <a:r>
+              <a:rPr lang="ru-RU" sz="2000" dirty="0" err="1"/>
+              <a:t>helm</a:t>
+            </a:r>
+            <a:r>
+              <a:rPr lang="ru-RU" sz="2000" dirty="0"/>
+              <a:t> </a:t>
+            </a:r>
+            <a:r>
+              <a:rPr lang="ru-RU" sz="2000" dirty="0" err="1"/>
+              <a:t>list</a:t>
+            </a:r>
+            <a:r>
+              <a:rPr lang="ru-RU" sz="2000" dirty="0"/>
+              <a:t> -n &lt;</a:t>
+            </a:r>
+            <a:r>
+              <a:rPr lang="ru-RU" sz="2000" dirty="0" err="1"/>
+              <a:t>namespace</a:t>
+            </a:r>
+            <a:r>
+              <a:rPr lang="ru-RU" sz="2000" dirty="0"/>
+              <a:t>&gt; –</a:t>
+            </a:r>
+            <a:r>
+              <a:rPr lang="en-US" sz="2000" dirty="0"/>
+              <a:t> </a:t>
+            </a:r>
+            <a:r>
+              <a:rPr lang="ru-RU" sz="2000" dirty="0"/>
+              <a:t>список релизов</a:t>
+            </a:r>
+          </a:p>
+          <a:p>
+            <a:pPr latinLnBrk="1"/>
+            <a:r>
+              <a:rPr lang="ru-RU" sz="2000" dirty="0" err="1"/>
+              <a:t>helm</a:t>
+            </a:r>
+            <a:r>
+              <a:rPr lang="ru-RU" sz="2000" dirty="0"/>
+              <a:t> </a:t>
+            </a:r>
+            <a:r>
+              <a:rPr lang="ru-RU" sz="2000" dirty="0" err="1"/>
+              <a:t>status</a:t>
+            </a:r>
+            <a:r>
+              <a:rPr lang="ru-RU" sz="2000" dirty="0"/>
+              <a:t> &lt;</a:t>
+            </a:r>
+            <a:r>
+              <a:rPr lang="ru-RU" sz="2000" dirty="0" err="1"/>
+              <a:t>release</a:t>
+            </a:r>
+            <a:r>
+              <a:rPr lang="ru-RU" sz="2000" dirty="0"/>
+              <a:t>&gt; -n &lt;</a:t>
+            </a:r>
+            <a:r>
+              <a:rPr lang="ru-RU" sz="2000" dirty="0" err="1"/>
+              <a:t>ns</a:t>
+            </a:r>
+            <a:r>
+              <a:rPr lang="ru-RU" sz="2000" dirty="0"/>
+              <a:t>&gt; – текущее состояние релиза</a:t>
+            </a:r>
+          </a:p>
+          <a:p>
+            <a:pPr latinLnBrk="1"/>
+            <a:r>
+              <a:rPr lang="ru-RU" sz="2000" dirty="0" err="1"/>
+              <a:t>helm</a:t>
+            </a:r>
+            <a:r>
+              <a:rPr lang="ru-RU" sz="2000" dirty="0"/>
+              <a:t> </a:t>
+            </a:r>
+            <a:r>
+              <a:rPr lang="ru-RU" sz="2000" dirty="0" err="1"/>
+              <a:t>history</a:t>
+            </a:r>
+            <a:r>
+              <a:rPr lang="ru-RU" sz="2000" dirty="0"/>
+              <a:t> &lt;</a:t>
+            </a:r>
+            <a:r>
+              <a:rPr lang="ru-RU" sz="2000" dirty="0" err="1"/>
+              <a:t>release</a:t>
+            </a:r>
+            <a:r>
+              <a:rPr lang="ru-RU" sz="2000" dirty="0"/>
+              <a:t>&gt; -n &lt;</a:t>
+            </a:r>
+            <a:r>
+              <a:rPr lang="ru-RU" sz="2000" dirty="0" err="1"/>
+              <a:t>ns</a:t>
+            </a:r>
+            <a:r>
+              <a:rPr lang="ru-RU" sz="2000" dirty="0"/>
+              <a:t>&gt; – история обновлений</a:t>
+            </a:r>
+          </a:p>
+          <a:p>
+            <a:pPr latinLnBrk="1"/>
+            <a:r>
+              <a:rPr lang="ru-RU" sz="2000" dirty="0" err="1"/>
+              <a:t>helm</a:t>
+            </a:r>
+            <a:r>
+              <a:rPr lang="ru-RU" sz="2000" dirty="0"/>
+              <a:t> </a:t>
+            </a:r>
+            <a:r>
+              <a:rPr lang="ru-RU" sz="2000" dirty="0" err="1"/>
+              <a:t>rollback</a:t>
+            </a:r>
+            <a:r>
+              <a:rPr lang="ru-RU" sz="2000" dirty="0"/>
+              <a:t> &lt;</a:t>
+            </a:r>
+            <a:r>
+              <a:rPr lang="ru-RU" sz="2000" dirty="0" err="1"/>
+              <a:t>release</a:t>
+            </a:r>
+            <a:r>
+              <a:rPr lang="ru-RU" sz="2000" dirty="0"/>
+              <a:t>&gt; &lt;номер&gt; – откат </a:t>
+            </a:r>
+            <a:r>
+              <a:rPr lang="ru-RU" sz="2000"/>
+              <a:t>к предыдущей версии</a:t>
+            </a:r>
+            <a:endParaRPr lang="ru-RU" sz="2000" dirty="0"/>
+          </a:p>
+        </p:txBody>
+      </p:sp>
+    </p:spTree>
+    <p:extLst>
+      <p:ext uri="{BB962C8B-B14F-4D97-AF65-F5344CB8AC3E}">
+        <p14:creationId xmlns:p14="http://schemas.microsoft.com/office/powerpoint/2010/main" val="1947830635"/>
+      </p:ext>
+    </p:extLst>
+  </p:cSld>
+  <p:clrMapOvr>
+    <a:masterClrMapping/>
+  </p:clrMapOvr>
+</p:sld>
+</file>
+
+<file path=ppt/slides/slide16.xml><?xml version="1.0" encoding="utf-8"?>
+<p:sld xmlns:a="http://schemas.openxmlformats.org/drawingml/2006/main" xmlns:r="http://schemas.openxmlformats.org/officeDocument/2006/relationships" xmlns:p="http://schemas.openxmlformats.org/presentationml/2006/main">
+  <p:cSld>
+    <p:spTree>
+      <p:nvGrpSpPr>
+        <p:cNvPr id="1" name="">
+          <a:extLst>
+            <a:ext uri="{FF2B5EF4-FFF2-40B4-BE49-F238E27FC236}">
+              <a16:creationId xmlns:a16="http://schemas.microsoft.com/office/drawing/2014/main" id="{90D59302-B29F-A628-31BC-717757686808}"/>
+            </a:ext>
+          </a:extLst>
+        </p:cNvPr>
+        <p:cNvGrpSpPr/>
+        <p:nvPr/>
+      </p:nvGrpSpPr>
+      <p:grpSpPr>
+        <a:xfrm>
+          <a:off x="0" y="0"/>
+          <a:ext cx="0" cy="0"/>
+          <a:chOff x="0" y="0"/>
+          <a:chExt cx="0" cy="0"/>
+        </a:xfrm>
+      </p:grpSpPr>
+      <p:sp>
+        <p:nvSpPr>
+          <p:cNvPr id="2" name="Заголовок 1">
+            <a:extLst>
+              <a:ext uri="{FF2B5EF4-FFF2-40B4-BE49-F238E27FC236}">
+                <a16:creationId xmlns:a16="http://schemas.microsoft.com/office/drawing/2014/main" id="{51911E1F-88C9-9E4A-5DE4-4C8BEDE3D1CB}"/>
+              </a:ext>
+            </a:extLst>
+          </p:cNvPr>
+          <p:cNvSpPr>
+            <a:spLocks noGrp="1"/>
+          </p:cNvSpPr>
+          <p:nvPr>
+            <p:ph type="title"/>
+          </p:nvPr>
+        </p:nvSpPr>
+        <p:spPr/>
+        <p:txBody>
+          <a:bodyPr/>
+          <a:lstStyle/>
+          <a:p>
+            <a:r>
+              <a:rPr lang="ru-RU" b="1" dirty="0">
+                <a:solidFill>
+                  <a:schemeClr val="accent1">
+                    <a:lumMod val="75000"/>
+                  </a:schemeClr>
+                </a:solidFill>
+              </a:rPr>
+              <a:t>Общие концепции. Kubernetes Service</a:t>
+            </a:r>
+          </a:p>
+        </p:txBody>
+      </p:sp>
+      <p:sp>
+        <p:nvSpPr>
+          <p:cNvPr id="9" name="Объект 8">
+            <a:extLst>
+              <a:ext uri="{FF2B5EF4-FFF2-40B4-BE49-F238E27FC236}">
+                <a16:creationId xmlns:a16="http://schemas.microsoft.com/office/drawing/2014/main" id="{5BA6A500-877A-F667-AA04-49FAAC605635}"/>
+              </a:ext>
+            </a:extLst>
+          </p:cNvPr>
+          <p:cNvSpPr>
+            <a:spLocks noGrp="1"/>
+          </p:cNvSpPr>
+          <p:nvPr>
+            <p:ph idx="1"/>
+          </p:nvPr>
+        </p:nvSpPr>
+        <p:spPr/>
+        <p:txBody>
+          <a:bodyPr>
+            <a:normAutofit fontScale="70000" lnSpcReduction="20000"/>
+          </a:bodyPr>
+          <a:lstStyle/>
+          <a:p>
+            <a:pPr marL="0" indent="0">
+              <a:buNone/>
+            </a:pPr>
+            <a:r>
+              <a:rPr lang="ru-RU" dirty="0" err="1"/>
+              <a:t>Pods</a:t>
+            </a:r>
+            <a:r>
+              <a:rPr lang="ru-RU" dirty="0"/>
+              <a:t> – это «расходный материал». Они могут завершаться, пересоздаваться или масштабироваться, поэтому при каждом создании получают новый IP-адрес. Из-за этого обращаться к </a:t>
+            </a:r>
+            <a:r>
+              <a:rPr lang="ru-RU" dirty="0" err="1"/>
+              <a:t>Pod</a:t>
+            </a:r>
+            <a:r>
+              <a:rPr lang="ru-RU" dirty="0"/>
+              <a:t> напрямую нельзя.</a:t>
+            </a:r>
+          </a:p>
+          <a:p>
+            <a:pPr marL="0" indent="0">
+              <a:buNone/>
+            </a:pPr>
+            <a:r>
+              <a:rPr lang="ru-RU" dirty="0"/>
+              <a:t>Для решения этой проблемы используется </a:t>
+            </a:r>
+            <a:r>
+              <a:rPr lang="ru-RU" b="1" dirty="0"/>
+              <a:t>Service</a:t>
+            </a:r>
+            <a:r>
+              <a:rPr lang="ru-RU" dirty="0"/>
+              <a:t>.</a:t>
+            </a:r>
+          </a:p>
+          <a:p>
+            <a:pPr marL="0" indent="0">
+              <a:buNone/>
+            </a:pPr>
+            <a:r>
+              <a:rPr lang="ru-RU" b="1" dirty="0"/>
+              <a:t>Service</a:t>
+            </a:r>
+            <a:r>
+              <a:rPr lang="ru-RU" dirty="0"/>
+              <a:t> – это объект </a:t>
+            </a:r>
+            <a:r>
+              <a:rPr lang="ru-RU" dirty="0" err="1"/>
+              <a:t>Kubernetes</a:t>
+            </a:r>
+            <a:r>
+              <a:rPr lang="ru-RU" dirty="0"/>
+              <a:t>, который предоставляет группе </a:t>
+            </a:r>
+            <a:r>
+              <a:rPr lang="ru-RU" dirty="0" err="1"/>
+              <a:t>Pod'ов</a:t>
+            </a:r>
+            <a:r>
+              <a:rPr lang="ru-RU" dirty="0"/>
+              <a:t> один постоянный внутренний IP-адрес и DNS-имя. Клиенты обращаются к Service, а </a:t>
+            </a:r>
+            <a:r>
+              <a:rPr lang="ru-RU" dirty="0" err="1"/>
+              <a:t>Kubernetes</a:t>
+            </a:r>
+            <a:r>
+              <a:rPr lang="ru-RU" dirty="0"/>
+              <a:t> автоматически перенаправляет запрос на один из подходящих </a:t>
+            </a:r>
+            <a:r>
+              <a:rPr lang="ru-RU" dirty="0" err="1"/>
+              <a:t>Pod'ов</a:t>
+            </a:r>
+            <a:r>
+              <a:rPr lang="ru-RU" dirty="0"/>
+              <a:t>.</a:t>
+            </a:r>
+          </a:p>
+          <a:p>
+            <a:pPr marL="0" indent="0">
+              <a:buNone/>
+            </a:pPr>
+            <a:r>
+              <a:rPr lang="ru-RU" b="1" dirty="0"/>
+              <a:t>Как Service находит нужные </a:t>
+            </a:r>
+            <a:r>
+              <a:rPr lang="ru-RU" b="1" dirty="0" err="1"/>
+              <a:t>Pod'ы</a:t>
+            </a:r>
+            <a:r>
+              <a:rPr lang="ru-RU" b="1" dirty="0"/>
+              <a:t>?</a:t>
+            </a:r>
+            <a:endParaRPr lang="ru-RU" dirty="0"/>
+          </a:p>
+          <a:p>
+            <a:r>
+              <a:rPr lang="ru-RU" b="1" dirty="0" err="1"/>
+              <a:t>Labels</a:t>
+            </a:r>
+            <a:r>
+              <a:rPr lang="ru-RU" b="1" dirty="0"/>
+              <a:t> (метки)</a:t>
+            </a:r>
+            <a:r>
+              <a:rPr lang="ru-RU" dirty="0"/>
+              <a:t> – назначаются </a:t>
+            </a:r>
+            <a:r>
+              <a:rPr lang="ru-RU" dirty="0" err="1"/>
+              <a:t>Pod'ам</a:t>
+            </a:r>
+            <a:r>
+              <a:rPr lang="ru-RU" dirty="0"/>
+              <a:t> (например, </a:t>
+            </a:r>
+            <a:r>
+              <a:rPr lang="ru-RU" dirty="0" err="1"/>
+              <a:t>app</a:t>
+            </a:r>
+            <a:r>
+              <a:rPr lang="ru-RU" dirty="0"/>
+              <a:t>: </a:t>
+            </a:r>
+            <a:r>
+              <a:rPr lang="ru-RU" dirty="0" err="1"/>
+              <a:t>payment-gateway</a:t>
+            </a:r>
+            <a:r>
+              <a:rPr lang="ru-RU" dirty="0"/>
+              <a:t>).</a:t>
+            </a:r>
+          </a:p>
+          <a:p>
+            <a:r>
+              <a:rPr lang="ru-RU" b="1" dirty="0" err="1"/>
+              <a:t>Selector</a:t>
+            </a:r>
+            <a:r>
+              <a:rPr lang="ru-RU" b="1" dirty="0"/>
+              <a:t> (селектор)</a:t>
+            </a:r>
+            <a:r>
+              <a:rPr lang="ru-RU" dirty="0"/>
+              <a:t> – указывается в Service и определяет, какие </a:t>
+            </a:r>
+            <a:r>
+              <a:rPr lang="ru-RU" dirty="0" err="1"/>
+              <a:t>Pod'ы</a:t>
+            </a:r>
+            <a:r>
+              <a:rPr lang="ru-RU" dirty="0"/>
+              <a:t> должны обслуживать запросы.</a:t>
+            </a:r>
+          </a:p>
+          <a:p>
+            <a:r>
+              <a:rPr lang="ru-RU" b="1" dirty="0" err="1"/>
+              <a:t>Endpoints</a:t>
+            </a:r>
+            <a:r>
+              <a:rPr lang="ru-RU" b="1" dirty="0"/>
+              <a:t> (конечные точки)</a:t>
+            </a:r>
+            <a:r>
+              <a:rPr lang="ru-RU" dirty="0"/>
+              <a:t> – </a:t>
+            </a:r>
+            <a:r>
+              <a:rPr lang="ru-RU" dirty="0" err="1"/>
+              <a:t>Kubernetes</a:t>
+            </a:r>
+            <a:r>
+              <a:rPr lang="ru-RU" dirty="0"/>
+              <a:t> автоматически формирует список IP-адресов всех </a:t>
+            </a:r>
+            <a:r>
+              <a:rPr lang="ru-RU" b="1" dirty="0"/>
+              <a:t>готовых</a:t>
+            </a:r>
+            <a:r>
+              <a:rPr lang="ru-RU" dirty="0"/>
+              <a:t> </a:t>
+            </a:r>
+            <a:r>
+              <a:rPr lang="ru-RU" dirty="0" err="1"/>
+              <a:t>Pod'ов</a:t>
+            </a:r>
+            <a:r>
+              <a:rPr lang="ru-RU" dirty="0"/>
+              <a:t>, подходящих под селектор. Именно на них Service распределяет входящий трафик.</a:t>
+            </a:r>
+            <a:br>
+              <a:rPr lang="ru-RU" dirty="0"/>
+            </a:br>
+            <a:r>
+              <a:rPr lang="ru-RU" i="1" dirty="0">
+                <a:solidFill>
+                  <a:schemeClr val="accent1">
+                    <a:lumMod val="75000"/>
+                  </a:schemeClr>
+                </a:solidFill>
+              </a:rPr>
+              <a:t>Если подходящих </a:t>
+            </a:r>
+            <a:r>
+              <a:rPr lang="ru-RU" i="1" dirty="0" err="1">
+                <a:solidFill>
+                  <a:schemeClr val="accent1">
+                    <a:lumMod val="75000"/>
+                  </a:schemeClr>
+                </a:solidFill>
+              </a:rPr>
+              <a:t>Pod'ов</a:t>
+            </a:r>
+            <a:r>
+              <a:rPr lang="ru-RU" i="1" dirty="0">
+                <a:solidFill>
+                  <a:schemeClr val="accent1">
+                    <a:lumMod val="75000"/>
+                  </a:schemeClr>
+                </a:solidFill>
+              </a:rPr>
+              <a:t> нет или они не готовы (</a:t>
+            </a:r>
+            <a:r>
+              <a:rPr lang="ru-RU" b="1" i="1" dirty="0">
+                <a:solidFill>
+                  <a:schemeClr val="accent1">
+                    <a:lumMod val="75000"/>
+                  </a:schemeClr>
+                </a:solidFill>
+              </a:rPr>
+              <a:t>Ready</a:t>
+            </a:r>
+            <a:r>
+              <a:rPr lang="ru-RU" i="1" dirty="0">
+                <a:solidFill>
+                  <a:schemeClr val="accent1">
+                    <a:lumMod val="75000"/>
+                  </a:schemeClr>
+                </a:solidFill>
+              </a:rPr>
+              <a:t>), список </a:t>
+            </a:r>
+            <a:r>
+              <a:rPr lang="ru-RU" i="1" dirty="0" err="1">
+                <a:solidFill>
+                  <a:schemeClr val="accent1">
+                    <a:lumMod val="75000"/>
+                  </a:schemeClr>
+                </a:solidFill>
+              </a:rPr>
+              <a:t>Endpoints</a:t>
+            </a:r>
+            <a:r>
+              <a:rPr lang="ru-RU" i="1" dirty="0">
+                <a:solidFill>
+                  <a:schemeClr val="accent1">
+                    <a:lumMod val="75000"/>
+                  </a:schemeClr>
+                </a:solidFill>
+              </a:rPr>
+              <a:t> будет пустым, и Service не сможет направить трафик.</a:t>
+            </a:r>
+          </a:p>
+        </p:txBody>
+      </p:sp>
+    </p:spTree>
+    <p:extLst>
+      <p:ext uri="{BB962C8B-B14F-4D97-AF65-F5344CB8AC3E}">
+        <p14:creationId xmlns:p14="http://schemas.microsoft.com/office/powerpoint/2010/main" val="530447079"/>
+      </p:ext>
+    </p:extLst>
+  </p:cSld>
+  <p:clrMapOvr>
+    <a:masterClrMapping/>
+  </p:clrMapOvr>
+</p:sld>
+</file>
+
+<file path=ppt/slides/slide17.xml><?xml version="1.0" encoding="utf-8"?>
 <p:sld xmlns:a="http://schemas.openxmlformats.org/drawingml/2006/main" xmlns:r="http://schemas.openxmlformats.org/officeDocument/2006/relationships" xmlns:p="http://schemas.openxmlformats.org/presentationml/2006/main">
   <p:cSld>
     <p:spTree>
@@ -4970,7 +5753,7 @@
 </p:sld>
 </file>
 
-<file path=ppt/slides/slide16.xml><?xml version="1.0" encoding="utf-8"?>
+<file path=ppt/slides/slide18.xml><?xml version="1.0" encoding="utf-8"?>
 <p:sld xmlns:a="http://schemas.openxmlformats.org/drawingml/2006/main" xmlns:r="http://schemas.openxmlformats.org/officeDocument/2006/relationships" xmlns:p="http://schemas.openxmlformats.org/presentationml/2006/main">
   <p:cSld>
     <p:spTree>
@@ -5142,7 +5925,7 @@
 </p:sld>
 </file>
 
-<file path=ppt/slides/slide17.xml><?xml version="1.0" encoding="utf-8"?>
+<file path=ppt/slides/slide19.xml><?xml version="1.0" encoding="utf-8"?>
 <p:sld xmlns:a="http://schemas.openxmlformats.org/drawingml/2006/main" xmlns:r="http://schemas.openxmlformats.org/officeDocument/2006/relationships" xmlns:p="http://schemas.openxmlformats.org/presentationml/2006/main">
   <p:cSld>
     <p:spTree>
@@ -5395,532 +6178,6 @@
     <p:extLst>
       <p:ext uri="{BB962C8B-B14F-4D97-AF65-F5344CB8AC3E}">
         <p14:creationId xmlns:p14="http://schemas.microsoft.com/office/powerpoint/2010/main" val="3345762599"/>
-      </p:ext>
-    </p:extLst>
-  </p:cSld>
-  <p:clrMapOvr>
-    <a:masterClrMapping/>
-  </p:clrMapOvr>
-</p:sld>
-</file>
-
-<file path=ppt/slides/slide18.xml><?xml version="1.0" encoding="utf-8"?>
-<p:sld xmlns:a="http://schemas.openxmlformats.org/drawingml/2006/main" xmlns:r="http://schemas.openxmlformats.org/officeDocument/2006/relationships" xmlns:p="http://schemas.openxmlformats.org/presentationml/2006/main">
-  <p:cSld>
-    <p:spTree>
-      <p:nvGrpSpPr>
-        <p:cNvPr id="1" name="">
-          <a:extLst>
-            <a:ext uri="{FF2B5EF4-FFF2-40B4-BE49-F238E27FC236}">
-              <a16:creationId xmlns:a16="http://schemas.microsoft.com/office/drawing/2014/main" id="{242308FF-FDB2-BA24-029C-C631578FECC9}"/>
-            </a:ext>
-          </a:extLst>
-        </p:cNvPr>
-        <p:cNvGrpSpPr/>
-        <p:nvPr/>
-      </p:nvGrpSpPr>
-      <p:grpSpPr>
-        <a:xfrm>
-          <a:off x="0" y="0"/>
-          <a:ext cx="0" cy="0"/>
-          <a:chOff x="0" y="0"/>
-          <a:chExt cx="0" cy="0"/>
-        </a:xfrm>
-      </p:grpSpPr>
-      <p:sp>
-        <p:nvSpPr>
-          <p:cNvPr id="2" name="Заголовок 1">
-            <a:extLst>
-              <a:ext uri="{FF2B5EF4-FFF2-40B4-BE49-F238E27FC236}">
-                <a16:creationId xmlns:a16="http://schemas.microsoft.com/office/drawing/2014/main" id="{DEF84094-F0D9-C447-A625-8B6F8E4BC21F}"/>
-              </a:ext>
-            </a:extLst>
-          </p:cNvPr>
-          <p:cNvSpPr>
-            <a:spLocks noGrp="1"/>
-          </p:cNvSpPr>
-          <p:nvPr>
-            <p:ph type="title"/>
-          </p:nvPr>
-        </p:nvSpPr>
-        <p:spPr/>
-        <p:txBody>
-          <a:bodyPr/>
-          <a:lstStyle/>
-          <a:p>
-            <a:r>
-              <a:rPr lang="ru-RU" b="1" dirty="0">
-                <a:solidFill>
-                  <a:schemeClr val="accent1">
-                    <a:lumMod val="75000"/>
-                  </a:schemeClr>
-                </a:solidFill>
-              </a:rPr>
-              <a:t>Общие концепции. </a:t>
-            </a:r>
-            <a:r>
-              <a:rPr lang="en-US" b="1" dirty="0">
-                <a:solidFill>
-                  <a:schemeClr val="accent1">
-                    <a:lumMod val="75000"/>
-                  </a:schemeClr>
-                </a:solidFill>
-              </a:rPr>
-              <a:t>Ingress</a:t>
-            </a:r>
-            <a:endParaRPr lang="ru-RU" b="1" dirty="0">
-              <a:solidFill>
-                <a:schemeClr val="accent1">
-                  <a:lumMod val="75000"/>
-                </a:schemeClr>
-              </a:solidFill>
-            </a:endParaRPr>
-          </a:p>
-        </p:txBody>
-      </p:sp>
-      <p:pic>
-        <p:nvPicPr>
-          <p:cNvPr id="5" name="Объект 4">
-            <a:extLst>
-              <a:ext uri="{FF2B5EF4-FFF2-40B4-BE49-F238E27FC236}">
-                <a16:creationId xmlns:a16="http://schemas.microsoft.com/office/drawing/2014/main" id="{D638B2F1-9E00-2E68-0493-5440C3862FD0}"/>
-              </a:ext>
-            </a:extLst>
-          </p:cNvPr>
-          <p:cNvPicPr>
-            <a:picLocks noGrp="1" noChangeAspect="1"/>
-          </p:cNvPicPr>
-          <p:nvPr>
-            <p:ph idx="1"/>
-          </p:nvPr>
-        </p:nvPicPr>
-        <p:blipFill>
-          <a:blip r:embed="rId2"/>
-          <a:stretch>
-            <a:fillRect/>
-          </a:stretch>
-        </p:blipFill>
-        <p:spPr>
-          <a:xfrm>
-            <a:off x="838200" y="2018004"/>
-            <a:ext cx="10515600" cy="3966579"/>
-          </a:xfrm>
-          <a:prstGeom prst="rect">
-            <a:avLst/>
-          </a:prstGeom>
-        </p:spPr>
-      </p:pic>
-    </p:spTree>
-    <p:extLst>
-      <p:ext uri="{BB962C8B-B14F-4D97-AF65-F5344CB8AC3E}">
-        <p14:creationId xmlns:p14="http://schemas.microsoft.com/office/powerpoint/2010/main" val="3591312026"/>
-      </p:ext>
-    </p:extLst>
-  </p:cSld>
-  <p:clrMapOvr>
-    <a:masterClrMapping/>
-  </p:clrMapOvr>
-</p:sld>
-</file>
-
-<file path=ppt/slides/slide19.xml><?xml version="1.0" encoding="utf-8"?>
-<p:sld xmlns:a="http://schemas.openxmlformats.org/drawingml/2006/main" xmlns:r="http://schemas.openxmlformats.org/officeDocument/2006/relationships" xmlns:p="http://schemas.openxmlformats.org/presentationml/2006/main">
-  <p:cSld>
-    <p:spTree>
-      <p:nvGrpSpPr>
-        <p:cNvPr id="1" name="">
-          <a:extLst>
-            <a:ext uri="{FF2B5EF4-FFF2-40B4-BE49-F238E27FC236}">
-              <a16:creationId xmlns:a16="http://schemas.microsoft.com/office/drawing/2014/main" id="{61578D6A-D563-06A4-478F-4C666A15E159}"/>
-            </a:ext>
-          </a:extLst>
-        </p:cNvPr>
-        <p:cNvGrpSpPr/>
-        <p:nvPr/>
-      </p:nvGrpSpPr>
-      <p:grpSpPr>
-        <a:xfrm>
-          <a:off x="0" y="0"/>
-          <a:ext cx="0" cy="0"/>
-          <a:chOff x="0" y="0"/>
-          <a:chExt cx="0" cy="0"/>
-        </a:xfrm>
-      </p:grpSpPr>
-      <p:sp>
-        <p:nvSpPr>
-          <p:cNvPr id="2" name="Заголовок 1">
-            <a:extLst>
-              <a:ext uri="{FF2B5EF4-FFF2-40B4-BE49-F238E27FC236}">
-                <a16:creationId xmlns:a16="http://schemas.microsoft.com/office/drawing/2014/main" id="{71F5121B-7CAA-E5A6-B7BF-334161B3E6F9}"/>
-              </a:ext>
-            </a:extLst>
-          </p:cNvPr>
-          <p:cNvSpPr>
-            <a:spLocks noGrp="1"/>
-          </p:cNvSpPr>
-          <p:nvPr>
-            <p:ph type="title"/>
-          </p:nvPr>
-        </p:nvSpPr>
-        <p:spPr/>
-        <p:txBody>
-          <a:bodyPr>
-            <a:normAutofit/>
-          </a:bodyPr>
-          <a:lstStyle/>
-          <a:p>
-            <a:r>
-              <a:rPr lang="ru-RU" sz="4300" b="1" dirty="0">
-                <a:solidFill>
-                  <a:schemeClr val="accent1">
-                    <a:lumMod val="75000"/>
-                  </a:schemeClr>
-                </a:solidFill>
-              </a:rPr>
-              <a:t>Поиск ошибок в цепочке </a:t>
-            </a:r>
-            <a:r>
-              <a:rPr lang="en-US" sz="4300" b="1" dirty="0">
-                <a:solidFill>
-                  <a:schemeClr val="accent1">
-                    <a:lumMod val="75000"/>
-                  </a:schemeClr>
-                </a:solidFill>
-              </a:rPr>
-              <a:t>Ingress-Service-Pod</a:t>
-            </a:r>
-            <a:endParaRPr lang="ru-RU" sz="4300" b="1" dirty="0">
-              <a:solidFill>
-                <a:schemeClr val="accent1">
-                  <a:lumMod val="75000"/>
-                </a:schemeClr>
-              </a:solidFill>
-            </a:endParaRPr>
-          </a:p>
-        </p:txBody>
-      </p:sp>
-      <p:sp>
-        <p:nvSpPr>
-          <p:cNvPr id="3" name="Объект 2">
-            <a:extLst>
-              <a:ext uri="{FF2B5EF4-FFF2-40B4-BE49-F238E27FC236}">
-                <a16:creationId xmlns:a16="http://schemas.microsoft.com/office/drawing/2014/main" id="{5D1AF8C7-1835-4CB8-4FB4-03C670C5D480}"/>
-              </a:ext>
-            </a:extLst>
-          </p:cNvPr>
-          <p:cNvSpPr>
-            <a:spLocks noGrp="1"/>
-          </p:cNvSpPr>
-          <p:nvPr>
-            <p:ph sz="half" idx="1"/>
-          </p:nvPr>
-        </p:nvSpPr>
-        <p:spPr/>
-        <p:txBody>
-          <a:bodyPr>
-            <a:normAutofit/>
-          </a:bodyPr>
-          <a:lstStyle/>
-          <a:p>
-            <a:pPr marL="0" indent="0">
-              <a:buNone/>
-            </a:pPr>
-            <a:r>
-              <a:rPr lang="ru-RU" sz="2600" b="1" dirty="0"/>
-              <a:t>QA (</a:t>
-            </a:r>
-            <a:r>
-              <a:rPr lang="ru-RU" sz="2600" b="1" dirty="0" err="1"/>
-              <a:t>Postman</a:t>
-            </a:r>
-            <a:r>
-              <a:rPr lang="ru-RU" sz="2600" b="1" dirty="0"/>
-              <a:t>/Браузер)</a:t>
-            </a:r>
-            <a:r>
-              <a:rPr lang="ru-RU" sz="2600" dirty="0"/>
-              <a:t> </a:t>
-            </a:r>
-            <a:endParaRPr lang="en-US" sz="2600" dirty="0"/>
-          </a:p>
-          <a:p>
-            <a:pPr marL="0" indent="0">
-              <a:buNone/>
-            </a:pPr>
-            <a:endParaRPr lang="ru-RU" sz="2600" dirty="0"/>
-          </a:p>
-          <a:p>
-            <a:pPr marL="0" indent="0">
-              <a:buNone/>
-            </a:pPr>
-            <a:r>
-              <a:rPr lang="ru-RU" sz="2600" b="1" dirty="0" err="1"/>
-              <a:t>Ingress</a:t>
-            </a:r>
-            <a:r>
-              <a:rPr lang="ru-RU" sz="2600" dirty="0"/>
-              <a:t> (разобрал URL</a:t>
-            </a:r>
-            <a:r>
-              <a:rPr lang="en-US" sz="2600" dirty="0"/>
-              <a:t> </a:t>
-            </a:r>
-            <a:r>
-              <a:rPr lang="ru-RU" sz="2600" dirty="0"/>
-              <a:t>«/</a:t>
-            </a:r>
-            <a:r>
-              <a:rPr lang="ru-RU" sz="2600" dirty="0" err="1"/>
-              <a:t>api</a:t>
-            </a:r>
-            <a:r>
-              <a:rPr lang="ru-RU" sz="2600" dirty="0"/>
-              <a:t>/</a:t>
-            </a:r>
-            <a:r>
-              <a:rPr lang="ru-RU" sz="2600" dirty="0" err="1"/>
-              <a:t>users</a:t>
-            </a:r>
-            <a:r>
-              <a:rPr lang="ru-RU" sz="2600" dirty="0"/>
-              <a:t>») </a:t>
-            </a:r>
-            <a:endParaRPr lang="en-US" sz="2600" dirty="0"/>
-          </a:p>
-          <a:p>
-            <a:pPr marL="0" indent="0">
-              <a:buNone/>
-            </a:pPr>
-            <a:endParaRPr lang="ru-RU" sz="2600" dirty="0"/>
-          </a:p>
-          <a:p>
-            <a:pPr marL="0" indent="0">
-              <a:buNone/>
-            </a:pPr>
-            <a:r>
-              <a:rPr lang="ru-RU" sz="2600" b="1" dirty="0"/>
-              <a:t>Service</a:t>
-            </a:r>
-            <a:r>
-              <a:rPr lang="ru-RU" sz="2600" dirty="0"/>
-              <a:t> (выбрал живой под по меткам, </a:t>
-            </a:r>
-            <a:r>
-              <a:rPr lang="en-US" sz="2600" dirty="0"/>
-              <a:t>users-backend-service</a:t>
-            </a:r>
-            <a:r>
-              <a:rPr lang="ru-RU" sz="2600" dirty="0"/>
-              <a:t>)</a:t>
-            </a:r>
-            <a:r>
-              <a:rPr lang="en-US" sz="2600" dirty="0"/>
-              <a:t> </a:t>
-            </a:r>
-          </a:p>
-          <a:p>
-            <a:pPr marL="0" indent="0">
-              <a:buNone/>
-            </a:pPr>
-            <a:endParaRPr lang="ru-RU" sz="2600" dirty="0"/>
-          </a:p>
-          <a:p>
-            <a:pPr marL="0" indent="0">
-              <a:buNone/>
-            </a:pPr>
-            <a:r>
-              <a:rPr lang="ru-RU" sz="2600" b="1" dirty="0" err="1"/>
-              <a:t>Pod</a:t>
-            </a:r>
-            <a:r>
-              <a:rPr lang="ru-RU" sz="2600" dirty="0"/>
-              <a:t> (обработал код и вернул</a:t>
-            </a:r>
-            <a:r>
-              <a:rPr lang="en-US" sz="2600" dirty="0"/>
-              <a:t> </a:t>
-            </a:r>
-            <a:r>
-              <a:rPr lang="ru-RU" sz="2600" dirty="0"/>
-              <a:t>ответ).</a:t>
-            </a:r>
-          </a:p>
-        </p:txBody>
-      </p:sp>
-      <p:pic>
-        <p:nvPicPr>
-          <p:cNvPr id="7" name="Объект 6" descr="How to debug Kubernetes? (Deployments, Services &amp; Ingress)">
-            <a:extLst>
-              <a:ext uri="{FF2B5EF4-FFF2-40B4-BE49-F238E27FC236}">
-                <a16:creationId xmlns:a16="http://schemas.microsoft.com/office/drawing/2014/main" id="{A76ECB88-FAC2-7B4E-3244-AD1D1750E58E}"/>
-              </a:ext>
-            </a:extLst>
-          </p:cNvPr>
-          <p:cNvPicPr>
-            <a:picLocks noGrp="1" noChangeAspect="1"/>
-          </p:cNvPicPr>
-          <p:nvPr>
-            <p:ph sz="half" idx="2"/>
-          </p:nvPr>
-        </p:nvPicPr>
-        <p:blipFill>
-          <a:blip r:embed="rId2"/>
-          <a:stretch>
-            <a:fillRect/>
-          </a:stretch>
-        </p:blipFill>
-        <p:spPr>
-          <a:xfrm>
-            <a:off x="6172200" y="2545056"/>
-            <a:ext cx="5181600" cy="2912476"/>
-          </a:xfrm>
-          <a:prstGeom prst="rect">
-            <a:avLst/>
-          </a:prstGeom>
-        </p:spPr>
-      </p:pic>
-      <p:sp>
-        <p:nvSpPr>
-          <p:cNvPr id="8" name="Стрелка: вниз 7">
-            <a:extLst>
-              <a:ext uri="{FF2B5EF4-FFF2-40B4-BE49-F238E27FC236}">
-                <a16:creationId xmlns:a16="http://schemas.microsoft.com/office/drawing/2014/main" id="{75C451B3-4EF9-680F-CF20-7F094C9912D3}"/>
-              </a:ext>
-            </a:extLst>
-          </p:cNvPr>
-          <p:cNvSpPr/>
-          <p:nvPr/>
-        </p:nvSpPr>
-        <p:spPr>
-          <a:xfrm>
-            <a:off x="1844040" y="4672584"/>
-            <a:ext cx="521208" cy="393192"/>
-          </a:xfrm>
-          <a:prstGeom prst="downArrow">
-            <a:avLst/>
-          </a:prstGeom>
-        </p:spPr>
-        <p:style>
-          <a:lnRef idx="2">
-            <a:schemeClr val="accent1">
-              <a:shade val="15000"/>
-            </a:schemeClr>
-          </a:lnRef>
-          <a:fillRef idx="1">
-            <a:schemeClr val="accent1"/>
-          </a:fillRef>
-          <a:effectRef idx="0">
-            <a:schemeClr val="accent1"/>
-          </a:effectRef>
-          <a:fontRef idx="minor">
-            <a:schemeClr val="lt1"/>
-          </a:fontRef>
-        </p:style>
-        <p:txBody>
-          <a:bodyPr rtlCol="0" anchor="ctr"/>
-          <a:lstStyle/>
-          <a:p>
-            <a:pPr algn="ctr"/>
-            <a:endParaRPr lang="ru-RU"/>
-          </a:p>
-        </p:txBody>
-      </p:sp>
-      <p:sp>
-        <p:nvSpPr>
-          <p:cNvPr id="10" name="Стрелка: вниз 9">
-            <a:extLst>
-              <a:ext uri="{FF2B5EF4-FFF2-40B4-BE49-F238E27FC236}">
-                <a16:creationId xmlns:a16="http://schemas.microsoft.com/office/drawing/2014/main" id="{72CF5F67-6F99-70DD-556D-6327469B6570}"/>
-              </a:ext>
-            </a:extLst>
-          </p:cNvPr>
-          <p:cNvSpPr/>
-          <p:nvPr/>
-        </p:nvSpPr>
-        <p:spPr>
-          <a:xfrm>
-            <a:off x="1844040" y="3328225"/>
-            <a:ext cx="521208" cy="393192"/>
-          </a:xfrm>
-          <a:prstGeom prst="downArrow">
-            <a:avLst/>
-          </a:prstGeom>
-        </p:spPr>
-        <p:style>
-          <a:lnRef idx="2">
-            <a:schemeClr val="accent1">
-              <a:shade val="15000"/>
-            </a:schemeClr>
-          </a:lnRef>
-          <a:fillRef idx="1">
-            <a:schemeClr val="accent1"/>
-          </a:fillRef>
-          <a:effectRef idx="0">
-            <a:schemeClr val="accent1"/>
-          </a:effectRef>
-          <a:fontRef idx="minor">
-            <a:schemeClr val="lt1"/>
-          </a:fontRef>
-        </p:style>
-        <p:txBody>
-          <a:bodyPr rtlCol="0" anchor="ctr"/>
-          <a:lstStyle/>
-          <a:p>
-            <a:pPr algn="ctr"/>
-            <a:endParaRPr lang="ru-RU"/>
-          </a:p>
-        </p:txBody>
-      </p:sp>
-      <p:sp>
-        <p:nvSpPr>
-          <p:cNvPr id="12" name="Стрелка: вниз 11">
-            <a:extLst>
-              <a:ext uri="{FF2B5EF4-FFF2-40B4-BE49-F238E27FC236}">
-                <a16:creationId xmlns:a16="http://schemas.microsoft.com/office/drawing/2014/main" id="{01D8A0F1-7187-70EC-5E60-F19B0ED9AED6}"/>
-              </a:ext>
-            </a:extLst>
-          </p:cNvPr>
-          <p:cNvSpPr/>
-          <p:nvPr/>
-        </p:nvSpPr>
-        <p:spPr>
-          <a:xfrm>
-            <a:off x="1845564" y="2348460"/>
-            <a:ext cx="521208" cy="393192"/>
-          </a:xfrm>
-          <a:prstGeom prst="downArrow">
-            <a:avLst/>
-          </a:prstGeom>
-        </p:spPr>
-        <p:style>
-          <a:lnRef idx="2">
-            <a:schemeClr val="accent1">
-              <a:shade val="15000"/>
-            </a:schemeClr>
-          </a:lnRef>
-          <a:fillRef idx="1">
-            <a:schemeClr val="accent1"/>
-          </a:fillRef>
-          <a:effectRef idx="0">
-            <a:schemeClr val="accent1"/>
-          </a:effectRef>
-          <a:fontRef idx="minor">
-            <a:schemeClr val="lt1"/>
-          </a:fontRef>
-        </p:style>
-        <p:txBody>
-          <a:bodyPr rtlCol="0" anchor="ctr"/>
-          <a:lstStyle/>
-          <a:p>
-            <a:pPr algn="ctr"/>
-            <a:endParaRPr lang="ru-RU"/>
-          </a:p>
-        </p:txBody>
-      </p:sp>
-    </p:spTree>
-    <p:extLst>
-      <p:ext uri="{BB962C8B-B14F-4D97-AF65-F5344CB8AC3E}">
-        <p14:creationId xmlns:p14="http://schemas.microsoft.com/office/powerpoint/2010/main" val="1354702285"/>
       </p:ext>
     </p:extLst>
   </p:cSld>
@@ -6219,6 +6476,532 @@
         <p:cNvPr id="1" name="">
           <a:extLst>
             <a:ext uri="{FF2B5EF4-FFF2-40B4-BE49-F238E27FC236}">
+              <a16:creationId xmlns:a16="http://schemas.microsoft.com/office/drawing/2014/main" id="{242308FF-FDB2-BA24-029C-C631578FECC9}"/>
+            </a:ext>
+          </a:extLst>
+        </p:cNvPr>
+        <p:cNvGrpSpPr/>
+        <p:nvPr/>
+      </p:nvGrpSpPr>
+      <p:grpSpPr>
+        <a:xfrm>
+          <a:off x="0" y="0"/>
+          <a:ext cx="0" cy="0"/>
+          <a:chOff x="0" y="0"/>
+          <a:chExt cx="0" cy="0"/>
+        </a:xfrm>
+      </p:grpSpPr>
+      <p:sp>
+        <p:nvSpPr>
+          <p:cNvPr id="2" name="Заголовок 1">
+            <a:extLst>
+              <a:ext uri="{FF2B5EF4-FFF2-40B4-BE49-F238E27FC236}">
+                <a16:creationId xmlns:a16="http://schemas.microsoft.com/office/drawing/2014/main" id="{DEF84094-F0D9-C447-A625-8B6F8E4BC21F}"/>
+              </a:ext>
+            </a:extLst>
+          </p:cNvPr>
+          <p:cNvSpPr>
+            <a:spLocks noGrp="1"/>
+          </p:cNvSpPr>
+          <p:nvPr>
+            <p:ph type="title"/>
+          </p:nvPr>
+        </p:nvSpPr>
+        <p:spPr/>
+        <p:txBody>
+          <a:bodyPr/>
+          <a:lstStyle/>
+          <a:p>
+            <a:r>
+              <a:rPr lang="ru-RU" b="1" dirty="0">
+                <a:solidFill>
+                  <a:schemeClr val="accent1">
+                    <a:lumMod val="75000"/>
+                  </a:schemeClr>
+                </a:solidFill>
+              </a:rPr>
+              <a:t>Общие концепции. </a:t>
+            </a:r>
+            <a:r>
+              <a:rPr lang="en-US" b="1" dirty="0">
+                <a:solidFill>
+                  <a:schemeClr val="accent1">
+                    <a:lumMod val="75000"/>
+                  </a:schemeClr>
+                </a:solidFill>
+              </a:rPr>
+              <a:t>Ingress</a:t>
+            </a:r>
+            <a:endParaRPr lang="ru-RU" b="1" dirty="0">
+              <a:solidFill>
+                <a:schemeClr val="accent1">
+                  <a:lumMod val="75000"/>
+                </a:schemeClr>
+              </a:solidFill>
+            </a:endParaRPr>
+          </a:p>
+        </p:txBody>
+      </p:sp>
+      <p:pic>
+        <p:nvPicPr>
+          <p:cNvPr id="5" name="Объект 4">
+            <a:extLst>
+              <a:ext uri="{FF2B5EF4-FFF2-40B4-BE49-F238E27FC236}">
+                <a16:creationId xmlns:a16="http://schemas.microsoft.com/office/drawing/2014/main" id="{D638B2F1-9E00-2E68-0493-5440C3862FD0}"/>
+              </a:ext>
+            </a:extLst>
+          </p:cNvPr>
+          <p:cNvPicPr>
+            <a:picLocks noGrp="1" noChangeAspect="1"/>
+          </p:cNvPicPr>
+          <p:nvPr>
+            <p:ph idx="1"/>
+          </p:nvPr>
+        </p:nvPicPr>
+        <p:blipFill>
+          <a:blip r:embed="rId2"/>
+          <a:stretch>
+            <a:fillRect/>
+          </a:stretch>
+        </p:blipFill>
+        <p:spPr>
+          <a:xfrm>
+            <a:off x="838200" y="2018004"/>
+            <a:ext cx="10515600" cy="3966579"/>
+          </a:xfrm>
+          <a:prstGeom prst="rect">
+            <a:avLst/>
+          </a:prstGeom>
+        </p:spPr>
+      </p:pic>
+    </p:spTree>
+    <p:extLst>
+      <p:ext uri="{BB962C8B-B14F-4D97-AF65-F5344CB8AC3E}">
+        <p14:creationId xmlns:p14="http://schemas.microsoft.com/office/powerpoint/2010/main" val="3591312026"/>
+      </p:ext>
+    </p:extLst>
+  </p:cSld>
+  <p:clrMapOvr>
+    <a:masterClrMapping/>
+  </p:clrMapOvr>
+</p:sld>
+</file>
+
+<file path=ppt/slides/slide21.xml><?xml version="1.0" encoding="utf-8"?>
+<p:sld xmlns:a="http://schemas.openxmlformats.org/drawingml/2006/main" xmlns:r="http://schemas.openxmlformats.org/officeDocument/2006/relationships" xmlns:p="http://schemas.openxmlformats.org/presentationml/2006/main">
+  <p:cSld>
+    <p:spTree>
+      <p:nvGrpSpPr>
+        <p:cNvPr id="1" name="">
+          <a:extLst>
+            <a:ext uri="{FF2B5EF4-FFF2-40B4-BE49-F238E27FC236}">
+              <a16:creationId xmlns:a16="http://schemas.microsoft.com/office/drawing/2014/main" id="{61578D6A-D563-06A4-478F-4C666A15E159}"/>
+            </a:ext>
+          </a:extLst>
+        </p:cNvPr>
+        <p:cNvGrpSpPr/>
+        <p:nvPr/>
+      </p:nvGrpSpPr>
+      <p:grpSpPr>
+        <a:xfrm>
+          <a:off x="0" y="0"/>
+          <a:ext cx="0" cy="0"/>
+          <a:chOff x="0" y="0"/>
+          <a:chExt cx="0" cy="0"/>
+        </a:xfrm>
+      </p:grpSpPr>
+      <p:sp>
+        <p:nvSpPr>
+          <p:cNvPr id="2" name="Заголовок 1">
+            <a:extLst>
+              <a:ext uri="{FF2B5EF4-FFF2-40B4-BE49-F238E27FC236}">
+                <a16:creationId xmlns:a16="http://schemas.microsoft.com/office/drawing/2014/main" id="{71F5121B-7CAA-E5A6-B7BF-334161B3E6F9}"/>
+              </a:ext>
+            </a:extLst>
+          </p:cNvPr>
+          <p:cNvSpPr>
+            <a:spLocks noGrp="1"/>
+          </p:cNvSpPr>
+          <p:nvPr>
+            <p:ph type="title"/>
+          </p:nvPr>
+        </p:nvSpPr>
+        <p:spPr/>
+        <p:txBody>
+          <a:bodyPr>
+            <a:normAutofit/>
+          </a:bodyPr>
+          <a:lstStyle/>
+          <a:p>
+            <a:r>
+              <a:rPr lang="ru-RU" sz="4300" b="1" dirty="0">
+                <a:solidFill>
+                  <a:schemeClr val="accent1">
+                    <a:lumMod val="75000"/>
+                  </a:schemeClr>
+                </a:solidFill>
+              </a:rPr>
+              <a:t>Поиск ошибок в цепочке </a:t>
+            </a:r>
+            <a:r>
+              <a:rPr lang="en-US" sz="4300" b="1" dirty="0">
+                <a:solidFill>
+                  <a:schemeClr val="accent1">
+                    <a:lumMod val="75000"/>
+                  </a:schemeClr>
+                </a:solidFill>
+              </a:rPr>
+              <a:t>Ingress-Service-Pod</a:t>
+            </a:r>
+            <a:endParaRPr lang="ru-RU" sz="4300" b="1" dirty="0">
+              <a:solidFill>
+                <a:schemeClr val="accent1">
+                  <a:lumMod val="75000"/>
+                </a:schemeClr>
+              </a:solidFill>
+            </a:endParaRPr>
+          </a:p>
+        </p:txBody>
+      </p:sp>
+      <p:sp>
+        <p:nvSpPr>
+          <p:cNvPr id="3" name="Объект 2">
+            <a:extLst>
+              <a:ext uri="{FF2B5EF4-FFF2-40B4-BE49-F238E27FC236}">
+                <a16:creationId xmlns:a16="http://schemas.microsoft.com/office/drawing/2014/main" id="{5D1AF8C7-1835-4CB8-4FB4-03C670C5D480}"/>
+              </a:ext>
+            </a:extLst>
+          </p:cNvPr>
+          <p:cNvSpPr>
+            <a:spLocks noGrp="1"/>
+          </p:cNvSpPr>
+          <p:nvPr>
+            <p:ph sz="half" idx="1"/>
+          </p:nvPr>
+        </p:nvSpPr>
+        <p:spPr/>
+        <p:txBody>
+          <a:bodyPr>
+            <a:normAutofit/>
+          </a:bodyPr>
+          <a:lstStyle/>
+          <a:p>
+            <a:pPr marL="0" indent="0">
+              <a:buNone/>
+            </a:pPr>
+            <a:r>
+              <a:rPr lang="ru-RU" sz="2600" b="1" dirty="0"/>
+              <a:t>QA (</a:t>
+            </a:r>
+            <a:r>
+              <a:rPr lang="ru-RU" sz="2600" b="1" dirty="0" err="1"/>
+              <a:t>Postman</a:t>
+            </a:r>
+            <a:r>
+              <a:rPr lang="ru-RU" sz="2600" b="1" dirty="0"/>
+              <a:t>/Браузер)</a:t>
+            </a:r>
+            <a:r>
+              <a:rPr lang="ru-RU" sz="2600" dirty="0"/>
+              <a:t> </a:t>
+            </a:r>
+            <a:endParaRPr lang="en-US" sz="2600" dirty="0"/>
+          </a:p>
+          <a:p>
+            <a:pPr marL="0" indent="0">
+              <a:buNone/>
+            </a:pPr>
+            <a:endParaRPr lang="ru-RU" sz="2600" dirty="0"/>
+          </a:p>
+          <a:p>
+            <a:pPr marL="0" indent="0">
+              <a:buNone/>
+            </a:pPr>
+            <a:r>
+              <a:rPr lang="ru-RU" sz="2600" b="1" dirty="0" err="1"/>
+              <a:t>Ingress</a:t>
+            </a:r>
+            <a:r>
+              <a:rPr lang="ru-RU" sz="2600" dirty="0"/>
+              <a:t> (разобрал URL</a:t>
+            </a:r>
+            <a:r>
+              <a:rPr lang="en-US" sz="2600" dirty="0"/>
+              <a:t> </a:t>
+            </a:r>
+            <a:r>
+              <a:rPr lang="ru-RU" sz="2600" dirty="0"/>
+              <a:t>«/</a:t>
+            </a:r>
+            <a:r>
+              <a:rPr lang="ru-RU" sz="2600" dirty="0" err="1"/>
+              <a:t>api</a:t>
+            </a:r>
+            <a:r>
+              <a:rPr lang="ru-RU" sz="2600" dirty="0"/>
+              <a:t>/</a:t>
+            </a:r>
+            <a:r>
+              <a:rPr lang="ru-RU" sz="2600" dirty="0" err="1"/>
+              <a:t>users</a:t>
+            </a:r>
+            <a:r>
+              <a:rPr lang="ru-RU" sz="2600" dirty="0"/>
+              <a:t>») </a:t>
+            </a:r>
+            <a:endParaRPr lang="en-US" sz="2600" dirty="0"/>
+          </a:p>
+          <a:p>
+            <a:pPr marL="0" indent="0">
+              <a:buNone/>
+            </a:pPr>
+            <a:endParaRPr lang="ru-RU" sz="2600" dirty="0"/>
+          </a:p>
+          <a:p>
+            <a:pPr marL="0" indent="0">
+              <a:buNone/>
+            </a:pPr>
+            <a:r>
+              <a:rPr lang="ru-RU" sz="2600" b="1" dirty="0"/>
+              <a:t>Service</a:t>
+            </a:r>
+            <a:r>
+              <a:rPr lang="ru-RU" sz="2600" dirty="0"/>
+              <a:t> (выбрал живой под по меткам, </a:t>
+            </a:r>
+            <a:r>
+              <a:rPr lang="en-US" sz="2600" dirty="0"/>
+              <a:t>users-backend-service</a:t>
+            </a:r>
+            <a:r>
+              <a:rPr lang="ru-RU" sz="2600" dirty="0"/>
+              <a:t>)</a:t>
+            </a:r>
+            <a:r>
+              <a:rPr lang="en-US" sz="2600" dirty="0"/>
+              <a:t> </a:t>
+            </a:r>
+          </a:p>
+          <a:p>
+            <a:pPr marL="0" indent="0">
+              <a:buNone/>
+            </a:pPr>
+            <a:endParaRPr lang="ru-RU" sz="2600" dirty="0"/>
+          </a:p>
+          <a:p>
+            <a:pPr marL="0" indent="0">
+              <a:buNone/>
+            </a:pPr>
+            <a:r>
+              <a:rPr lang="ru-RU" sz="2600" b="1" dirty="0" err="1"/>
+              <a:t>Pod</a:t>
+            </a:r>
+            <a:r>
+              <a:rPr lang="ru-RU" sz="2600" dirty="0"/>
+              <a:t> (обработал код и вернул</a:t>
+            </a:r>
+            <a:r>
+              <a:rPr lang="en-US" sz="2600" dirty="0"/>
+              <a:t> </a:t>
+            </a:r>
+            <a:r>
+              <a:rPr lang="ru-RU" sz="2600" dirty="0"/>
+              <a:t>ответ).</a:t>
+            </a:r>
+          </a:p>
+        </p:txBody>
+      </p:sp>
+      <p:pic>
+        <p:nvPicPr>
+          <p:cNvPr id="7" name="Объект 6" descr="How to debug Kubernetes? (Deployments, Services &amp; Ingress)">
+            <a:extLst>
+              <a:ext uri="{FF2B5EF4-FFF2-40B4-BE49-F238E27FC236}">
+                <a16:creationId xmlns:a16="http://schemas.microsoft.com/office/drawing/2014/main" id="{A76ECB88-FAC2-7B4E-3244-AD1D1750E58E}"/>
+              </a:ext>
+            </a:extLst>
+          </p:cNvPr>
+          <p:cNvPicPr>
+            <a:picLocks noGrp="1" noChangeAspect="1"/>
+          </p:cNvPicPr>
+          <p:nvPr>
+            <p:ph sz="half" idx="2"/>
+          </p:nvPr>
+        </p:nvPicPr>
+        <p:blipFill>
+          <a:blip r:embed="rId2"/>
+          <a:stretch>
+            <a:fillRect/>
+          </a:stretch>
+        </p:blipFill>
+        <p:spPr>
+          <a:xfrm>
+            <a:off x="6172200" y="2545056"/>
+            <a:ext cx="5181600" cy="2912476"/>
+          </a:xfrm>
+          <a:prstGeom prst="rect">
+            <a:avLst/>
+          </a:prstGeom>
+        </p:spPr>
+      </p:pic>
+      <p:sp>
+        <p:nvSpPr>
+          <p:cNvPr id="8" name="Стрелка: вниз 7">
+            <a:extLst>
+              <a:ext uri="{FF2B5EF4-FFF2-40B4-BE49-F238E27FC236}">
+                <a16:creationId xmlns:a16="http://schemas.microsoft.com/office/drawing/2014/main" id="{75C451B3-4EF9-680F-CF20-7F094C9912D3}"/>
+              </a:ext>
+            </a:extLst>
+          </p:cNvPr>
+          <p:cNvSpPr/>
+          <p:nvPr/>
+        </p:nvSpPr>
+        <p:spPr>
+          <a:xfrm>
+            <a:off x="1844040" y="4672584"/>
+            <a:ext cx="521208" cy="393192"/>
+          </a:xfrm>
+          <a:prstGeom prst="downArrow">
+            <a:avLst/>
+          </a:prstGeom>
+        </p:spPr>
+        <p:style>
+          <a:lnRef idx="2">
+            <a:schemeClr val="accent1">
+              <a:shade val="15000"/>
+            </a:schemeClr>
+          </a:lnRef>
+          <a:fillRef idx="1">
+            <a:schemeClr val="accent1"/>
+          </a:fillRef>
+          <a:effectRef idx="0">
+            <a:schemeClr val="accent1"/>
+          </a:effectRef>
+          <a:fontRef idx="minor">
+            <a:schemeClr val="lt1"/>
+          </a:fontRef>
+        </p:style>
+        <p:txBody>
+          <a:bodyPr rtlCol="0" anchor="ctr"/>
+          <a:lstStyle/>
+          <a:p>
+            <a:pPr algn="ctr"/>
+            <a:endParaRPr lang="ru-RU"/>
+          </a:p>
+        </p:txBody>
+      </p:sp>
+      <p:sp>
+        <p:nvSpPr>
+          <p:cNvPr id="10" name="Стрелка: вниз 9">
+            <a:extLst>
+              <a:ext uri="{FF2B5EF4-FFF2-40B4-BE49-F238E27FC236}">
+                <a16:creationId xmlns:a16="http://schemas.microsoft.com/office/drawing/2014/main" id="{72CF5F67-6F99-70DD-556D-6327469B6570}"/>
+              </a:ext>
+            </a:extLst>
+          </p:cNvPr>
+          <p:cNvSpPr/>
+          <p:nvPr/>
+        </p:nvSpPr>
+        <p:spPr>
+          <a:xfrm>
+            <a:off x="1844040" y="3328225"/>
+            <a:ext cx="521208" cy="393192"/>
+          </a:xfrm>
+          <a:prstGeom prst="downArrow">
+            <a:avLst/>
+          </a:prstGeom>
+        </p:spPr>
+        <p:style>
+          <a:lnRef idx="2">
+            <a:schemeClr val="accent1">
+              <a:shade val="15000"/>
+            </a:schemeClr>
+          </a:lnRef>
+          <a:fillRef idx="1">
+            <a:schemeClr val="accent1"/>
+          </a:fillRef>
+          <a:effectRef idx="0">
+            <a:schemeClr val="accent1"/>
+          </a:effectRef>
+          <a:fontRef idx="minor">
+            <a:schemeClr val="lt1"/>
+          </a:fontRef>
+        </p:style>
+        <p:txBody>
+          <a:bodyPr rtlCol="0" anchor="ctr"/>
+          <a:lstStyle/>
+          <a:p>
+            <a:pPr algn="ctr"/>
+            <a:endParaRPr lang="ru-RU"/>
+          </a:p>
+        </p:txBody>
+      </p:sp>
+      <p:sp>
+        <p:nvSpPr>
+          <p:cNvPr id="12" name="Стрелка: вниз 11">
+            <a:extLst>
+              <a:ext uri="{FF2B5EF4-FFF2-40B4-BE49-F238E27FC236}">
+                <a16:creationId xmlns:a16="http://schemas.microsoft.com/office/drawing/2014/main" id="{01D8A0F1-7187-70EC-5E60-F19B0ED9AED6}"/>
+              </a:ext>
+            </a:extLst>
+          </p:cNvPr>
+          <p:cNvSpPr/>
+          <p:nvPr/>
+        </p:nvSpPr>
+        <p:spPr>
+          <a:xfrm>
+            <a:off x="1845564" y="2348460"/>
+            <a:ext cx="521208" cy="393192"/>
+          </a:xfrm>
+          <a:prstGeom prst="downArrow">
+            <a:avLst/>
+          </a:prstGeom>
+        </p:spPr>
+        <p:style>
+          <a:lnRef idx="2">
+            <a:schemeClr val="accent1">
+              <a:shade val="15000"/>
+            </a:schemeClr>
+          </a:lnRef>
+          <a:fillRef idx="1">
+            <a:schemeClr val="accent1"/>
+          </a:fillRef>
+          <a:effectRef idx="0">
+            <a:schemeClr val="accent1"/>
+          </a:effectRef>
+          <a:fontRef idx="minor">
+            <a:schemeClr val="lt1"/>
+          </a:fontRef>
+        </p:style>
+        <p:txBody>
+          <a:bodyPr rtlCol="0" anchor="ctr"/>
+          <a:lstStyle/>
+          <a:p>
+            <a:pPr algn="ctr"/>
+            <a:endParaRPr lang="ru-RU"/>
+          </a:p>
+        </p:txBody>
+      </p:sp>
+    </p:spTree>
+    <p:extLst>
+      <p:ext uri="{BB962C8B-B14F-4D97-AF65-F5344CB8AC3E}">
+        <p14:creationId xmlns:p14="http://schemas.microsoft.com/office/powerpoint/2010/main" val="1354702285"/>
+      </p:ext>
+    </p:extLst>
+  </p:cSld>
+  <p:clrMapOvr>
+    <a:masterClrMapping/>
+  </p:clrMapOvr>
+</p:sld>
+</file>
+
+<file path=ppt/slides/slide22.xml><?xml version="1.0" encoding="utf-8"?>
+<p:sld xmlns:a="http://schemas.openxmlformats.org/drawingml/2006/main" xmlns:r="http://schemas.openxmlformats.org/officeDocument/2006/relationships" xmlns:p="http://schemas.openxmlformats.org/presentationml/2006/main">
+  <p:cSld>
+    <p:spTree>
+      <p:nvGrpSpPr>
+        <p:cNvPr id="1" name="">
+          <a:extLst>
+            <a:ext uri="{FF2B5EF4-FFF2-40B4-BE49-F238E27FC236}">
               <a16:creationId xmlns:a16="http://schemas.microsoft.com/office/drawing/2014/main" id="{26EB0A25-FFD1-3231-983A-22778D4CCD08}"/>
             </a:ext>
           </a:extLst>
@@ -6820,7 +7603,7 @@
 </p:sld>
 </file>
 
-<file path=ppt/slides/slide21.xml><?xml version="1.0" encoding="utf-8"?>
+<file path=ppt/slides/slide23.xml><?xml version="1.0" encoding="utf-8"?>
 <p:sld xmlns:a="http://schemas.openxmlformats.org/drawingml/2006/main" xmlns:r="http://schemas.openxmlformats.org/officeDocument/2006/relationships" xmlns:p="http://schemas.openxmlformats.org/presentationml/2006/main">
   <p:cSld>
     <p:spTree>
@@ -7251,7 +8034,7 @@
 </p:sld>
 </file>
 
-<file path=ppt/slides/slide22.xml><?xml version="1.0" encoding="utf-8"?>
+<file path=ppt/slides/slide24.xml><?xml version="1.0" encoding="utf-8"?>
 <p:sld xmlns:a="http://schemas.openxmlformats.org/drawingml/2006/main" xmlns:r="http://schemas.openxmlformats.org/officeDocument/2006/relationships" xmlns:p="http://schemas.openxmlformats.org/presentationml/2006/main">
   <p:cSld>
     <p:spTree>
@@ -7402,7 +8185,7 @@
 </p:sld>
 </file>
 
-<file path=ppt/slides/slide23.xml><?xml version="1.0" encoding="utf-8"?>
+<file path=ppt/slides/slide25.xml><?xml version="1.0" encoding="utf-8"?>
 <p:sld xmlns:a="http://schemas.openxmlformats.org/drawingml/2006/main" xmlns:r="http://schemas.openxmlformats.org/officeDocument/2006/relationships" xmlns:p="http://schemas.openxmlformats.org/presentationml/2006/main">
   <p:cSld>
     <p:spTree>
@@ -7855,7 +8638,7 @@
 </p:sld>
 </file>
 
-<file path=ppt/slides/slide24.xml><?xml version="1.0" encoding="utf-8"?>
+<file path=ppt/slides/slide26.xml><?xml version="1.0" encoding="utf-8"?>
 <p:sld xmlns:a="http://schemas.openxmlformats.org/drawingml/2006/main" xmlns:r="http://schemas.openxmlformats.org/officeDocument/2006/relationships" xmlns:p="http://schemas.openxmlformats.org/presentationml/2006/main">
   <p:cSld>
     <p:spTree>
@@ -8279,7 +9062,7 @@
 </p:sld>
 </file>
 
-<file path=ppt/slides/slide25.xml><?xml version="1.0" encoding="utf-8"?>
+<file path=ppt/slides/slide27.xml><?xml version="1.0" encoding="utf-8"?>
 <p:sld xmlns:a="http://schemas.openxmlformats.org/drawingml/2006/main" xmlns:r="http://schemas.openxmlformats.org/officeDocument/2006/relationships" xmlns:p="http://schemas.openxmlformats.org/presentationml/2006/main">
   <p:cSld>
     <p:spTree>
@@ -8453,7 +9236,7 @@
 </p:sld>
 </file>
 
-<file path=ppt/slides/slide26.xml><?xml version="1.0" encoding="utf-8"?>
+<file path=ppt/slides/slide28.xml><?xml version="1.0" encoding="utf-8"?>
 <p:sld xmlns:a="http://schemas.openxmlformats.org/drawingml/2006/main" xmlns:r="http://schemas.openxmlformats.org/officeDocument/2006/relationships" xmlns:p="http://schemas.openxmlformats.org/presentationml/2006/main">
   <p:cSld>
     <p:spTree>
@@ -10090,7 +10873,7 @@
         </p:nvSpPr>
         <p:spPr>
           <a:xfrm>
-            <a:off x="587406" y="4580521"/>
+            <a:off x="662511" y="4306201"/>
             <a:ext cx="351378" cy="707886"/>
           </a:xfrm>
           <a:prstGeom prst="rect">

</xml_diff>